<commit_message>
Add exp64-66 experiment cards, COVER paper reference, and briefing PPT assets
Records the map/polish time-share governor (exp64), budget-constrained
GS-SLAM plan + LM-RS/CaRtGS/Taming-3DGS survey (exp65/66), and the newly
downloaded COVER (CVPR 2026) reference paper used for the exp66 view
selection audit.

Co-Authored-By: Claude Sonnet 5 <noreply@anthropic.com>
Claude-Session: https://claude.ai/code/session_01JJBEjv2SSvSFz5TsTtZXro
</commit_message>
<xml_diff>
--- a/context/ppt/ppt0812/vigs_budget_briefing_0812.pptx
+++ b/context/ppt/ppt0812/vigs_budget_briefing_0812.pptx
@@ -20,6 +20,10 @@
     <p:sldId id="268" r:id="rId19"/>
     <p:sldId id="269" r:id="rId20"/>
     <p:sldId id="270" r:id="rId21"/>
+    <p:sldId id="271" r:id="rId22"/>
+    <p:sldId id="272" r:id="rId23"/>
+    <p:sldId id="273" r:id="rId24"/>
+    <p:sldId id="274" r:id="rId25"/>
   </p:sldIdLst>
   <p:sldSz cx="12191695" cy="6858000" type="screen4x3"/>
   <p:notesSz cx="6858000" cy="9144000"/>
@@ -3414,7 +3418,7 @@
                 </a:solidFill>
                 <a:latin typeface="Noto Sans CJK KR"/>
               </a:rPr>
-              <a:t>MEASURED · BONUS</a:t>
+              <a:t>MEASURED · STEP 1</a:t>
             </a:r>
           </a:p>
         </p:txBody>
@@ -3453,7 +3457,7 @@
                 </a:solidFill>
                 <a:latin typeface="Noto Sans CJK KR"/>
               </a:rPr>
-              <a:t>실측 결과 ③ — map() 자체는 두 씬 모두 같은 구성</a:t>
+              <a:t>실측 결과 ① — frontend가 진짜 지배적이다</a:t>
             </a:r>
           </a:p>
         </p:txBody>
@@ -3504,7 +3508,7 @@
       </p:sp>
       <p:pic>
         <p:nvPicPr>
-          <p:cNvPr id="6" name="Picture 5" descr="fig_map_breakdown.png"/>
+          <p:cNvPr id="6" name="Picture 5" descr="fig_frontend_scaling.png"/>
           <p:cNvPicPr>
             <a:picLocks noChangeAspect="1"/>
           </p:cNvPicPr>
@@ -3518,8 +3522,8 @@
         </p:blipFill>
         <p:spPr>
           <a:xfrm>
-            <a:off x="2826673" y="1280160"/>
-            <a:ext cx="6538347" cy="3703320"/>
+            <a:off x="3111452" y="1280160"/>
+            <a:ext cx="5968790" cy="3794760"/>
           </a:xfrm>
           <a:prstGeom prst="rect">
             <a:avLst/>
@@ -3528,39 +3532,207 @@
       </p:pic>
       <p:sp>
         <p:nvSpPr>
-          <p:cNvPr id="7" name="TextBox 6"/>
-          <p:cNvSpPr txBox="1"/>
+          <p:cNvPr id="7" name="Rounded Rectangle 6"/>
+          <p:cNvSpPr/>
           <p:nvPr/>
         </p:nvSpPr>
         <p:spPr>
           <a:xfrm>
             <a:off x="548640" y="5257800"/>
-            <a:ext cx="11094415" cy="1005840"/>
-          </a:xfrm>
-          <a:prstGeom prst="rect">
-            <a:avLst/>
-          </a:prstGeom>
-          <a:noFill/>
-        </p:spPr>
-        <p:txBody>
-          <a:bodyPr wrap="square" anchor="t">
-            <a:spAutoFit/>
-          </a:bodyPr>
-          <a:lstStyle/>
-          <a:p>
-            <a:pPr algn="l">
-              <a:lnSpc>
-                <a:spcPct val="125000"/>
-              </a:lnSpc>
-            </a:pPr>
-            <a:r>
-              <a:rPr sz="1250" b="0">
+            <a:ext cx="3566160" cy="1005840"/>
+          </a:xfrm>
+          <a:prstGeom prst="roundRect">
+            <a:avLst>
+              <a:gd name="adj" fmla="val 8000"/>
+            </a:avLst>
+          </a:prstGeom>
+          <a:solidFill>
+            <a:srgbClr val="1A1F2B"/>
+          </a:solidFill>
+          <a:ln w="15875">
+            <a:solidFill>
+              <a:srgbClr val="EF6A5C"/>
+            </a:solidFill>
+          </a:ln>
+          <a:effectLst/>
+        </p:spPr>
+        <p:style>
+          <a:lnRef idx="1">
+            <a:schemeClr val="accent1"/>
+          </a:lnRef>
+          <a:fillRef idx="3">
+            <a:schemeClr val="accent1"/>
+          </a:fillRef>
+          <a:effectRef idx="2">
+            <a:schemeClr val="accent1"/>
+          </a:effectRef>
+          <a:fontRef idx="minor">
+            <a:schemeClr val="lt1"/>
+          </a:fontRef>
+        </p:style>
+        <p:txBody>
+          <a:bodyPr rtlCol="0" anchor="ctr" wrap="square" lIns="146304" rIns="146304"/>
+          <a:lstStyle/>
+          <a:p>
+            <a:pPr algn="ctr"/>
+            <a:r>
+              <a:rPr sz="2200" b="1">
+                <a:solidFill>
+                  <a:srgbClr val="EF6A5C"/>
+                </a:solidFill>
+                <a:latin typeface="Noto Sans CJK KR"/>
+              </a:rPr>
+              <a:t>73.4%</a:t>
+            </a:r>
+          </a:p>
+          <a:p>
+            <a:pPr algn="ctr"/>
+            <a:r>
+              <a:rPr sz="1050">
                 <a:solidFill>
                   <a:srgbClr val="8B95AB"/>
                 </a:solidFill>
                 <a:latin typeface="Noto Sans CJK KR"/>
               </a:rPr>
-              <a:t>loss_compute+backward가 두 씬 모두 ~90%로 지배적, rasterize는 ~7~8%뿐 — map() 자체의 내부 구성은 씬에 따라 거의 안 변한다. 즉 12F가 나빠진 원인은 map() 내부가 아니라 map()이 dispatch되기 전 단계(frontend가 얼마나 자주·오래 도는가)에 있다는 게 다시 확인된다.</a:t>
+              <a:t>12F A2 frontend 비중</a:t>
+            </a:r>
+          </a:p>
+        </p:txBody>
+      </p:sp>
+      <p:sp>
+        <p:nvSpPr>
+          <p:cNvPr id="8" name="Rounded Rectangle 7"/>
+          <p:cNvSpPr/>
+          <p:nvPr/>
+        </p:nvSpPr>
+        <p:spPr>
+          <a:xfrm>
+            <a:off x="4297679" y="5257800"/>
+            <a:ext cx="3566160" cy="1005840"/>
+          </a:xfrm>
+          <a:prstGeom prst="roundRect">
+            <a:avLst>
+              <a:gd name="adj" fmla="val 8000"/>
+            </a:avLst>
+          </a:prstGeom>
+          <a:solidFill>
+            <a:srgbClr val="1A1F2B"/>
+          </a:solidFill>
+          <a:ln w="15875">
+            <a:solidFill>
+              <a:srgbClr val="FFB454"/>
+            </a:solidFill>
+          </a:ln>
+          <a:effectLst/>
+        </p:spPr>
+        <p:style>
+          <a:lnRef idx="1">
+            <a:schemeClr val="accent1"/>
+          </a:lnRef>
+          <a:fillRef idx="3">
+            <a:schemeClr val="accent1"/>
+          </a:fillRef>
+          <a:effectRef idx="2">
+            <a:schemeClr val="accent1"/>
+          </a:effectRef>
+          <a:fontRef idx="minor">
+            <a:schemeClr val="lt1"/>
+          </a:fontRef>
+        </p:style>
+        <p:txBody>
+          <a:bodyPr rtlCol="0" anchor="ctr" wrap="square" lIns="146304" rIns="146304"/>
+          <a:lstStyle/>
+          <a:p>
+            <a:pPr algn="ctr"/>
+            <a:r>
+              <a:rPr sz="2200" b="1">
+                <a:solidFill>
+                  <a:srgbClr val="FFB454"/>
+                </a:solidFill>
+                <a:latin typeface="Noto Sans CJK KR"/>
+              </a:rPr>
+              <a:t>×2.17</a:t>
+            </a:r>
+          </a:p>
+          <a:p>
+            <a:pPr algn="ctr"/>
+            <a:r>
+              <a:rPr sz="1050">
+                <a:solidFill>
+                  <a:srgbClr val="8B95AB"/>
+                </a:solidFill>
+                <a:latin typeface="Noto Sans CJK KR"/>
+              </a:rPr>
+              <a:t>iters1 1→2 배율</a:t>
+            </a:r>
+          </a:p>
+        </p:txBody>
+      </p:sp>
+      <p:sp>
+        <p:nvSpPr>
+          <p:cNvPr id="9" name="Rounded Rectangle 8"/>
+          <p:cNvSpPr/>
+          <p:nvPr/>
+        </p:nvSpPr>
+        <p:spPr>
+          <a:xfrm>
+            <a:off x="8046719" y="5257800"/>
+            <a:ext cx="3657600" cy="1005840"/>
+          </a:xfrm>
+          <a:prstGeom prst="roundRect">
+            <a:avLst>
+              <a:gd name="adj" fmla="val 8000"/>
+            </a:avLst>
+          </a:prstGeom>
+          <a:solidFill>
+            <a:srgbClr val="1A1F2B"/>
+          </a:solidFill>
+          <a:ln w="15875">
+            <a:solidFill>
+              <a:srgbClr val="8B95AB"/>
+            </a:solidFill>
+          </a:ln>
+          <a:effectLst/>
+        </p:spPr>
+        <p:style>
+          <a:lnRef idx="1">
+            <a:schemeClr val="accent1"/>
+          </a:lnRef>
+          <a:fillRef idx="3">
+            <a:schemeClr val="accent1"/>
+          </a:fillRef>
+          <a:effectRef idx="2">
+            <a:schemeClr val="accent1"/>
+          </a:effectRef>
+          <a:fontRef idx="minor">
+            <a:schemeClr val="lt1"/>
+          </a:fontRef>
+        </p:style>
+        <p:txBody>
+          <a:bodyPr rtlCol="0" anchor="ctr" wrap="square" lIns="146304" rIns="146304"/>
+          <a:lstStyle/>
+          <a:p>
+            <a:pPr algn="ctr"/>
+            <a:r>
+              <a:rPr sz="2200" b="1">
+                <a:solidFill>
+                  <a:srgbClr val="8B95AB"/>
+                </a:solidFill>
+                <a:latin typeface="Noto Sans CJK KR"/>
+              </a:rPr>
+              <a:t>1.2~1.7%</a:t>
+            </a:r>
+          </a:p>
+          <a:p>
+            <a:pPr algn="ctr"/>
+            <a:r>
+              <a:rPr sz="1050">
+                <a:solidFill>
+                  <a:srgbClr val="8B95AB"/>
+                </a:solidFill>
+                <a:latin typeface="Noto Sans CJK KR"/>
+              </a:rPr>
+              <a:t>gs_mapping(디스패치) 비중</a:t>
             </a:r>
           </a:p>
         </p:txBody>
@@ -3661,7 +3833,7 @@
                 </a:solidFill>
                 <a:latin typeface="Noto Sans CJK KR"/>
               </a:rPr>
-              <a:t>MEASURED · STEP 3</a:t>
+              <a:t>MEASURED · STEP 2</a:t>
             </a:r>
           </a:p>
         </p:txBody>
@@ -3700,7 +3872,7 @@
                 </a:solidFill>
                 <a:latin typeface="Noto Sans CJK KR"/>
               </a:rPr>
-              <a:t>실측 결과 ④ — 예산을 33% 늘리면 회귀가 거의 회복된다 (역-U자형)</a:t>
+              <a:t>실측 결과 ② — polish는 "느려진 게" 아니라 "기회가 없었다"</a:t>
             </a:r>
           </a:p>
         </p:txBody>
@@ -3751,7 +3923,7 @@
       </p:sp>
       <p:pic>
         <p:nvPicPr>
-          <p:cNvPr id="6" name="Picture 5" descr="fig_scale_sweep.png"/>
+          <p:cNvPr id="6" name="Picture 5" descr="fig_polish_opportunity.png"/>
           <p:cNvPicPr>
             <a:picLocks noChangeAspect="1"/>
           </p:cNvPicPr>
@@ -3765,8 +3937,8 @@
         </p:blipFill>
         <p:spPr>
           <a:xfrm>
-            <a:off x="2725178" y="1280160"/>
-            <a:ext cx="6741337" cy="3794760"/>
+            <a:off x="2929308" y="1280160"/>
+            <a:ext cx="6333078" cy="3794760"/>
           </a:xfrm>
           <a:prstGeom prst="rect">
             <a:avLst/>
@@ -3775,207 +3947,39 @@
       </p:pic>
       <p:sp>
         <p:nvSpPr>
-          <p:cNvPr id="7" name="Rounded Rectangle 6"/>
-          <p:cNvSpPr/>
+          <p:cNvPr id="7" name="TextBox 6"/>
+          <p:cNvSpPr txBox="1"/>
           <p:nvPr/>
         </p:nvSpPr>
         <p:spPr>
           <a:xfrm>
             <a:off x="548640" y="5257800"/>
-            <a:ext cx="3566160" cy="1005840"/>
-          </a:xfrm>
-          <a:prstGeom prst="roundRect">
-            <a:avLst>
-              <a:gd name="adj" fmla="val 8000"/>
-            </a:avLst>
-          </a:prstGeom>
-          <a:solidFill>
-            <a:srgbClr val="1A1F2B"/>
-          </a:solidFill>
-          <a:ln w="15875">
-            <a:solidFill>
-              <a:srgbClr val="5FD68A"/>
-            </a:solidFill>
-          </a:ln>
-          <a:effectLst/>
-        </p:spPr>
-        <p:style>
-          <a:lnRef idx="1">
-            <a:schemeClr val="accent1"/>
-          </a:lnRef>
-          <a:fillRef idx="3">
-            <a:schemeClr val="accent1"/>
-          </a:fillRef>
-          <a:effectRef idx="2">
-            <a:schemeClr val="accent1"/>
-          </a:effectRef>
-          <a:fontRef idx="minor">
-            <a:schemeClr val="lt1"/>
-          </a:fontRef>
-        </p:style>
-        <p:txBody>
-          <a:bodyPr rtlCol="0" anchor="ctr" wrap="square" lIns="146304" rIns="146304"/>
-          <a:lstStyle/>
-          <a:p>
-            <a:pPr algn="ctr"/>
-            <a:r>
-              <a:rPr sz="2200" b="1">
-                <a:solidFill>
-                  <a:srgbClr val="5FD68A"/>
-                </a:solidFill>
-                <a:latin typeface="Noto Sans CJK KR"/>
-              </a:rPr>
-              <a:t>+4.26 dB</a:t>
-            </a:r>
-          </a:p>
-          <a:p>
-            <a:pPr algn="ctr"/>
-            <a:r>
-              <a:rPr sz="1050">
-                <a:solidFill>
-                  <a:srgbClr val="8B95AB"/>
-                </a:solidFill>
-                <a:latin typeface="Noto Sans CJK KR"/>
-              </a:rPr>
-              <a:t>scale 1.5→2.0</a:t>
-            </a:r>
-          </a:p>
-        </p:txBody>
-      </p:sp>
-      <p:sp>
-        <p:nvSpPr>
-          <p:cNvPr id="8" name="Rounded Rectangle 7"/>
-          <p:cNvSpPr/>
-          <p:nvPr/>
-        </p:nvSpPr>
-        <p:spPr>
-          <a:xfrm>
-            <a:off x="4297679" y="5257800"/>
-            <a:ext cx="3566160" cy="1005840"/>
-          </a:xfrm>
-          <a:prstGeom prst="roundRect">
-            <a:avLst>
-              <a:gd name="adj" fmla="val 8000"/>
-            </a:avLst>
-          </a:prstGeom>
-          <a:solidFill>
-            <a:srgbClr val="1A1F2B"/>
-          </a:solidFill>
-          <a:ln w="15875">
-            <a:solidFill>
-              <a:srgbClr val="EF6A5C"/>
-            </a:solidFill>
-          </a:ln>
-          <a:effectLst/>
-        </p:spPr>
-        <p:style>
-          <a:lnRef idx="1">
-            <a:schemeClr val="accent1"/>
-          </a:lnRef>
-          <a:fillRef idx="3">
-            <a:schemeClr val="accent1"/>
-          </a:fillRef>
-          <a:effectRef idx="2">
-            <a:schemeClr val="accent1"/>
-          </a:effectRef>
-          <a:fontRef idx="minor">
-            <a:schemeClr val="lt1"/>
-          </a:fontRef>
-        </p:style>
-        <p:txBody>
-          <a:bodyPr rtlCol="0" anchor="ctr" wrap="square" lIns="146304" rIns="146304"/>
-          <a:lstStyle/>
-          <a:p>
-            <a:pPr algn="ctr"/>
-            <a:r>
-              <a:rPr sz="2200" b="1">
-                <a:solidFill>
-                  <a:srgbClr val="EF6A5C"/>
-                </a:solidFill>
-                <a:latin typeface="Noto Sans CJK KR"/>
-              </a:rPr>
-              <a:t>-2.13 dB</a:t>
-            </a:r>
-          </a:p>
-          <a:p>
-            <a:pPr algn="ctr"/>
-            <a:r>
-              <a:rPr sz="1050">
-                <a:solidFill>
-                  <a:srgbClr val="8B95AB"/>
-                </a:solidFill>
-                <a:latin typeface="Noto Sans CJK KR"/>
-              </a:rPr>
-              <a:t>scale 2.0→3.0</a:t>
-            </a:r>
-          </a:p>
-        </p:txBody>
-      </p:sp>
-      <p:sp>
-        <p:nvSpPr>
-          <p:cNvPr id="9" name="Rounded Rectangle 8"/>
-          <p:cNvSpPr/>
-          <p:nvPr/>
-        </p:nvSpPr>
-        <p:spPr>
-          <a:xfrm>
-            <a:off x="8046719" y="5257800"/>
-            <a:ext cx="3657600" cy="1005840"/>
-          </a:xfrm>
-          <a:prstGeom prst="roundRect">
-            <a:avLst>
-              <a:gd name="adj" fmla="val 8000"/>
-            </a:avLst>
-          </a:prstGeom>
-          <a:solidFill>
-            <a:srgbClr val="1A1F2B"/>
-          </a:solidFill>
-          <a:ln w="15875">
-            <a:solidFill>
-              <a:srgbClr val="FFB454"/>
-            </a:solidFill>
-          </a:ln>
-          <a:effectLst/>
-        </p:spPr>
-        <p:style>
-          <a:lnRef idx="1">
-            <a:schemeClr val="accent1"/>
-          </a:lnRef>
-          <a:fillRef idx="3">
-            <a:schemeClr val="accent1"/>
-          </a:fillRef>
-          <a:effectRef idx="2">
-            <a:schemeClr val="accent1"/>
-          </a:effectRef>
-          <a:fontRef idx="minor">
-            <a:schemeClr val="lt1"/>
-          </a:fontRef>
-        </p:style>
-        <p:txBody>
-          <a:bodyPr rtlCol="0" anchor="ctr" wrap="square" lIns="146304" rIns="146304"/>
-          <a:lstStyle/>
-          <a:p>
-            <a:pPr algn="ctr"/>
-            <a:r>
-              <a:rPr sz="2200" b="1">
-                <a:solidFill>
-                  <a:srgbClr val="FFB454"/>
-                </a:solidFill>
-                <a:latin typeface="Noto Sans CJK KR"/>
-              </a:rPr>
-              <a:t>10,000 캡 도달</a:t>
-            </a:r>
-          </a:p>
-          <a:p>
-            <a:pPr algn="ctr"/>
-            <a:r>
-              <a:rPr sz="1050">
-                <a:solidFill>
-                  <a:srgbClr val="8B95AB"/>
-                </a:solidFill>
-                <a:latin typeface="Noto Sans CJK KR"/>
-              </a:rPr>
-              <a:t>polish 3.0 상태</a:t>
+            <a:ext cx="11094415" cy="1005840"/>
+          </a:xfrm>
+          <a:prstGeom prst="rect">
+            <a:avLst/>
+          </a:prstGeom>
+          <a:noFill/>
+        </p:spPr>
+        <p:txBody>
+          <a:bodyPr wrap="square" anchor="t">
+            <a:spAutoFit/>
+          </a:bodyPr>
+          <a:lstStyle/>
+          <a:p>
+            <a:pPr algn="l">
+              <a:lnSpc>
+                <a:spcPct val="125000"/>
+              </a:lnSpc>
+            </a:pPr>
+            <a:r>
+              <a:rPr sz="1250" b="0">
+                <a:solidFill>
+                  <a:srgbClr val="E8ECF4"/>
+                </a:solidFill>
+                <a:latin typeface="Noto Sans CJK KR"/>
+              </a:rPr>
+              <a:t>핵심 확인: call당 비용(3.9~6.4ms)은 gaussian 수(40k~150k)에 걸쳐 거의 고정 — 미세한 n_gauss 의존성은 있지만(약 1.5배 범위) 기회 횟수 차이(13배)에 비하면 훨씬 작다. 즉 exp카드에 남겼던 "772 step이 idle 부족 때문인지 step 자체가 느려서인지" 질문의 답은 확정적으로 idle 부족 쪽이다.</a:t>
             </a:r>
           </a:p>
         </p:txBody>
@@ -4076,7 +4080,7 @@
                 </a:solidFill>
                 <a:latin typeface="Noto Sans CJK KR"/>
               </a:rPr>
-              <a:t>MEASURED · STEP 4</a:t>
+              <a:t>MEASURED · BONUS</a:t>
             </a:r>
           </a:p>
         </p:txBody>
@@ -4115,7 +4119,7 @@
                 </a:solidFill>
                 <a:latin typeface="Noto Sans CJK KR"/>
               </a:rPr>
-              <a:t>실측 결과 ⑤ — polish 횟수가 "계단식"으로 보였던 진짜 이유</a:t>
+              <a:t>실측 결과 ③ — map() 자체는 두 씬 모두 같은 구성</a:t>
             </a:r>
           </a:p>
         </p:txBody>
@@ -4166,7 +4170,7 @@
       </p:sp>
       <p:pic>
         <p:nvPicPr>
-          <p:cNvPr id="6" name="Picture 5" descr="fig_gap_quantization.png"/>
+          <p:cNvPr id="6" name="Picture 5" descr="fig_map_breakdown.png"/>
           <p:cNvPicPr>
             <a:picLocks noChangeAspect="1"/>
           </p:cNvPicPr>
@@ -4180,8 +4184,8 @@
         </p:blipFill>
         <p:spPr>
           <a:xfrm>
-            <a:off x="2587378" y="1280160"/>
-            <a:ext cx="7016937" cy="3794760"/>
+            <a:off x="2826673" y="1280160"/>
+            <a:ext cx="6538347" cy="3703320"/>
           </a:xfrm>
           <a:prstGeom prst="rect">
             <a:avLst/>
@@ -4196,7 +4200,7 @@
         </p:nvSpPr>
         <p:spPr>
           <a:xfrm>
-            <a:off x="548640" y="5349240"/>
+            <a:off x="548640" y="5257800"/>
             <a:ext cx="11094415" cy="1005840"/>
           </a:xfrm>
           <a:prstGeom prst="rect">
@@ -4216,13 +4220,13 @@
               </a:lnSpc>
             </a:pPr>
             <a:r>
-              <a:rPr sz="1200" b="0">
+              <a:rPr sz="1250" b="0">
                 <a:solidFill>
                   <a:srgbClr val="8B95AB"/>
                 </a:solidFill>
                 <a:latin typeface="Noto Sans CJK KR"/>
               </a:rPr>
-              <a:t>gs_worker_dispatch/background_polish_call에 epoch 타임스탬프를 추가해 디스패치 사이 gap을 직접 재구성했다. 총 polish 횟수는 각 gap 길이를 step당 비용(4~6ms)으로 나눈 정수 몫의 합 — gap의 43~57%는 아예 1개도 못 낄 만큼 짧아 "부드러운 비례"가 아니라 본질적으로 계단식이다. scale이 커질수록 긴 gap(최대 526→1582→2478ms)이 늘어나며 총량이 늘지만, 3.0의 역행은 이 메커니즘만으론 설명 안 됨 — 좁은 후보 풀(stride-5 rgb_dense) 과적합 가설 필요(미검증).</a:t>
+              <a:t>loss_compute+backward가 두 씬 모두 ~90%로 지배적, rasterize는 ~7~8%뿐 — map() 자체의 내부 구성은 씬에 따라 거의 안 변한다. 즉 12F가 나빠진 원인은 map() 내부가 아니라 map()이 dispatch되기 전 단계(frontend가 얼마나 자주·오래 도는가)에 있다는 게 다시 확인된다.</a:t>
             </a:r>
           </a:p>
         </p:txBody>
@@ -4323,7 +4327,7 @@
                 </a:solidFill>
                 <a:latin typeface="Noto Sans CJK KR"/>
               </a:rPr>
-              <a:t>FOUR DIRECTIONS</a:t>
+              <a:t>MEASURED · STEP 3</a:t>
             </a:r>
           </a:p>
         </p:txBody>
@@ -4362,7 +4366,7 @@
                 </a:solidFill>
                 <a:latin typeface="Noto Sans CJK KR"/>
               </a:rPr>
-              <a:t>다음에 정해야 할 4가지 — 전부 같은 문제의 다른 얼굴</a:t>
+              <a:t>실측 결과 ④ — 예산을 33% 늘리면 회귀가 거의 회복된다 (역-U자형)</a:t>
             </a:r>
           </a:p>
         </p:txBody>
@@ -4411,26 +4415,188 @@
           </a:p>
         </p:txBody>
       </p:sp>
-      <p:sp>
-        <p:nvSpPr>
-          <p:cNvPr id="6" name="Rounded Rectangle 5"/>
+      <p:pic>
+        <p:nvPicPr>
+          <p:cNvPr id="6" name="Picture 5" descr="fig_scale_sweep.png"/>
+          <p:cNvPicPr>
+            <a:picLocks noChangeAspect="1"/>
+          </p:cNvPicPr>
+          <p:nvPr/>
+        </p:nvPicPr>
+        <p:blipFill>
+          <a:blip r:embed="rId2"/>
+          <a:stretch>
+            <a:fillRect/>
+          </a:stretch>
+        </p:blipFill>
+        <p:spPr>
+          <a:xfrm>
+            <a:off x="2725178" y="1280160"/>
+            <a:ext cx="6741337" cy="3794760"/>
+          </a:xfrm>
+          <a:prstGeom prst="rect">
+            <a:avLst/>
+          </a:prstGeom>
+        </p:spPr>
+      </p:pic>
+      <p:sp>
+        <p:nvSpPr>
+          <p:cNvPr id="7" name="Rounded Rectangle 6"/>
           <p:cNvSpPr/>
           <p:nvPr/>
         </p:nvSpPr>
         <p:spPr>
           <a:xfrm>
-            <a:off x="548640" y="1417320"/>
-            <a:ext cx="1600200" cy="292608"/>
+            <a:off x="548640" y="5257800"/>
+            <a:ext cx="3566160" cy="1005840"/>
           </a:xfrm>
           <a:prstGeom prst="roundRect">
             <a:avLst>
-              <a:gd name="adj" fmla="val 50000"/>
+              <a:gd name="adj" fmla="val 8000"/>
             </a:avLst>
           </a:prstGeom>
           <a:solidFill>
             <a:srgbClr val="1A1F2B"/>
           </a:solidFill>
-          <a:ln w="12700">
+          <a:ln w="15875">
+            <a:solidFill>
+              <a:srgbClr val="5FD68A"/>
+            </a:solidFill>
+          </a:ln>
+          <a:effectLst/>
+        </p:spPr>
+        <p:style>
+          <a:lnRef idx="1">
+            <a:schemeClr val="accent1"/>
+          </a:lnRef>
+          <a:fillRef idx="3">
+            <a:schemeClr val="accent1"/>
+          </a:fillRef>
+          <a:effectRef idx="2">
+            <a:schemeClr val="accent1"/>
+          </a:effectRef>
+          <a:fontRef idx="minor">
+            <a:schemeClr val="lt1"/>
+          </a:fontRef>
+        </p:style>
+        <p:txBody>
+          <a:bodyPr rtlCol="0" anchor="ctr" wrap="square" lIns="146304" rIns="146304"/>
+          <a:lstStyle/>
+          <a:p>
+            <a:pPr algn="ctr"/>
+            <a:r>
+              <a:rPr sz="2200" b="1">
+                <a:solidFill>
+                  <a:srgbClr val="5FD68A"/>
+                </a:solidFill>
+                <a:latin typeface="Noto Sans CJK KR"/>
+              </a:rPr>
+              <a:t>+4.26 dB</a:t>
+            </a:r>
+          </a:p>
+          <a:p>
+            <a:pPr algn="ctr"/>
+            <a:r>
+              <a:rPr sz="1050">
+                <a:solidFill>
+                  <a:srgbClr val="8B95AB"/>
+                </a:solidFill>
+                <a:latin typeface="Noto Sans CJK KR"/>
+              </a:rPr>
+              <a:t>scale 1.5→2.0</a:t>
+            </a:r>
+          </a:p>
+        </p:txBody>
+      </p:sp>
+      <p:sp>
+        <p:nvSpPr>
+          <p:cNvPr id="8" name="Rounded Rectangle 7"/>
+          <p:cNvSpPr/>
+          <p:nvPr/>
+        </p:nvSpPr>
+        <p:spPr>
+          <a:xfrm>
+            <a:off x="4297679" y="5257800"/>
+            <a:ext cx="3566160" cy="1005840"/>
+          </a:xfrm>
+          <a:prstGeom prst="roundRect">
+            <a:avLst>
+              <a:gd name="adj" fmla="val 8000"/>
+            </a:avLst>
+          </a:prstGeom>
+          <a:solidFill>
+            <a:srgbClr val="1A1F2B"/>
+          </a:solidFill>
+          <a:ln w="15875">
+            <a:solidFill>
+              <a:srgbClr val="EF6A5C"/>
+            </a:solidFill>
+          </a:ln>
+          <a:effectLst/>
+        </p:spPr>
+        <p:style>
+          <a:lnRef idx="1">
+            <a:schemeClr val="accent1"/>
+          </a:lnRef>
+          <a:fillRef idx="3">
+            <a:schemeClr val="accent1"/>
+          </a:fillRef>
+          <a:effectRef idx="2">
+            <a:schemeClr val="accent1"/>
+          </a:effectRef>
+          <a:fontRef idx="minor">
+            <a:schemeClr val="lt1"/>
+          </a:fontRef>
+        </p:style>
+        <p:txBody>
+          <a:bodyPr rtlCol="0" anchor="ctr" wrap="square" lIns="146304" rIns="146304"/>
+          <a:lstStyle/>
+          <a:p>
+            <a:pPr algn="ctr"/>
+            <a:r>
+              <a:rPr sz="2200" b="1">
+                <a:solidFill>
+                  <a:srgbClr val="EF6A5C"/>
+                </a:solidFill>
+                <a:latin typeface="Noto Sans CJK KR"/>
+              </a:rPr>
+              <a:t>-2.13 dB</a:t>
+            </a:r>
+          </a:p>
+          <a:p>
+            <a:pPr algn="ctr"/>
+            <a:r>
+              <a:rPr sz="1050">
+                <a:solidFill>
+                  <a:srgbClr val="8B95AB"/>
+                </a:solidFill>
+                <a:latin typeface="Noto Sans CJK KR"/>
+              </a:rPr>
+              <a:t>scale 2.0→3.0</a:t>
+            </a:r>
+          </a:p>
+        </p:txBody>
+      </p:sp>
+      <p:sp>
+        <p:nvSpPr>
+          <p:cNvPr id="9" name="Rounded Rectangle 8"/>
+          <p:cNvSpPr/>
+          <p:nvPr/>
+        </p:nvSpPr>
+        <p:spPr>
+          <a:xfrm>
+            <a:off x="8046719" y="5257800"/>
+            <a:ext cx="3657600" cy="1005840"/>
+          </a:xfrm>
+          <a:prstGeom prst="roundRect">
+            <a:avLst>
+              <a:gd name="adj" fmla="val 8000"/>
+            </a:avLst>
+          </a:prstGeom>
+          <a:solidFill>
+            <a:srgbClr val="1A1F2B"/>
+          </a:solidFill>
+          <a:ln w="15875">
             <a:solidFill>
               <a:srgbClr val="FFB454"/>
             </a:solidFill>
@@ -4452,384 +4618,30 @@
           </a:fontRef>
         </p:style>
         <p:txBody>
-          <a:bodyPr rtlCol="0" anchor="ctr" lIns="45720" rIns="45720"/>
+          <a:bodyPr rtlCol="0" anchor="ctr" wrap="square" lIns="146304" rIns="146304"/>
           <a:lstStyle/>
           <a:p>
             <a:pPr algn="ctr"/>
             <a:r>
-              <a:rPr sz="950" b="1">
+              <a:rPr sz="2200" b="1">
                 <a:solidFill>
                   <a:srgbClr val="FFB454"/>
                 </a:solidFill>
                 <a:latin typeface="Noto Sans CJK KR"/>
               </a:rPr>
-              <a:t>① FREEZE 기준</a:t>
-            </a:r>
-          </a:p>
-        </p:txBody>
-      </p:sp>
-      <p:sp>
-        <p:nvSpPr>
-          <p:cNvPr id="7" name="TextBox 6"/>
-          <p:cNvSpPr txBox="1"/>
-          <p:nvPr/>
-        </p:nvSpPr>
-        <p:spPr>
-          <a:xfrm>
-            <a:off x="2331720" y="1389888"/>
-            <a:ext cx="9311335" cy="457200"/>
-          </a:xfrm>
-          <a:prstGeom prst="rect">
-            <a:avLst/>
-          </a:prstGeom>
-          <a:noFill/>
-        </p:spPr>
-        <p:txBody>
-          <a:bodyPr wrap="square" anchor="ctr">
-            <a:spAutoFit/>
-          </a:bodyPr>
-          <a:lstStyle/>
-          <a:p>
-            <a:pPr algn="l">
-              <a:lnSpc>
-                <a:spcPct val="100000"/>
-              </a:lnSpc>
-            </a:pPr>
-            <a:r>
-              <a:rPr sz="1250" b="0">
-                <a:solidFill>
-                  <a:srgbClr val="E8ECF4"/>
-                </a:solidFill>
-                <a:latin typeface="Noto Sans CJK KR"/>
-              </a:rPr>
-              <a:t>`mapping_freeze_after_frac` 고정 비율(0.6140)은 1253/305 튜닝값일 뿐 원리적 근거 없음 — 12F 회귀가 직접 반례. coverage/densify-rate/loss-plateau 중 robust한 기준 필요.</a:t>
-            </a:r>
-          </a:p>
-        </p:txBody>
-      </p:sp>
-      <p:sp>
-        <p:nvSpPr>
-          <p:cNvPr id="8" name="Rounded Rectangle 7"/>
-          <p:cNvSpPr/>
-          <p:nvPr/>
-        </p:nvSpPr>
-        <p:spPr>
-          <a:xfrm>
-            <a:off x="548640" y="2377440"/>
-            <a:ext cx="1600200" cy="292608"/>
-          </a:xfrm>
-          <a:prstGeom prst="roundRect">
-            <a:avLst>
-              <a:gd name="adj" fmla="val 50000"/>
-            </a:avLst>
-          </a:prstGeom>
-          <a:solidFill>
-            <a:srgbClr val="1A1F2B"/>
-          </a:solidFill>
-          <a:ln w="12700">
-            <a:solidFill>
-              <a:srgbClr val="4C86EA"/>
-            </a:solidFill>
-          </a:ln>
-          <a:effectLst/>
-        </p:spPr>
-        <p:style>
-          <a:lnRef idx="1">
-            <a:schemeClr val="accent1"/>
-          </a:lnRef>
-          <a:fillRef idx="3">
-            <a:schemeClr val="accent1"/>
-          </a:fillRef>
-          <a:effectRef idx="2">
-            <a:schemeClr val="accent1"/>
-          </a:effectRef>
-          <a:fontRef idx="minor">
-            <a:schemeClr val="lt1"/>
-          </a:fontRef>
-        </p:style>
-        <p:txBody>
-          <a:bodyPr rtlCol="0" anchor="ctr" lIns="45720" rIns="45720"/>
-          <a:lstStyle/>
+              <a:t>10,000 캡 도달</a:t>
+            </a:r>
+          </a:p>
           <a:p>
             <a:pPr algn="ctr"/>
             <a:r>
-              <a:rPr sz="950" b="1">
-                <a:solidFill>
-                  <a:srgbClr val="4C86EA"/>
-                </a:solidFill>
-                <a:latin typeface="Noto Sans CJK KR"/>
-              </a:rPr>
-              <a:t>② CARVE LOSS 이식</a:t>
-            </a:r>
-          </a:p>
-        </p:txBody>
-      </p:sp>
-      <p:sp>
-        <p:nvSpPr>
-          <p:cNvPr id="9" name="TextBox 8"/>
-          <p:cNvSpPr txBox="1"/>
-          <p:nvPr/>
-        </p:nvSpPr>
-        <p:spPr>
-          <a:xfrm>
-            <a:off x="2331720" y="2350008"/>
-            <a:ext cx="9311335" cy="457200"/>
-          </a:xfrm>
-          <a:prstGeom prst="rect">
-            <a:avLst/>
-          </a:prstGeom>
-          <a:noFill/>
-        </p:spPr>
-        <p:txBody>
-          <a:bodyPr wrap="square" anchor="ctr">
-            <a:spAutoFit/>
-          </a:bodyPr>
-          <a:lstStyle/>
-          <a:p>
-            <a:pPr algn="l">
-              <a:lnSpc>
-                <a:spcPct val="100000"/>
-              </a:lnSpc>
-            </a:pPr>
-            <a:r>
-              <a:rPr sz="1250" b="0">
-                <a:solidFill>
-                  <a:srgbClr val="E8ECF4"/>
-                </a:solidFill>
-                <a:latin typeface="Noto Sans CJK KR"/>
-              </a:rPr>
-              <a:t>배치에서 검증된 방법론(exp44d2, 33.8dB)을 density/pruning 결정에 이식. 단, 12F 재튜닝 전이라 3장면 다 27dB 안정화 전 — CLAUDE.md 순서 제약과 맞물림.</a:t>
-            </a:r>
-          </a:p>
-        </p:txBody>
-      </p:sp>
-      <p:sp>
-        <p:nvSpPr>
-          <p:cNvPr id="10" name="Rounded Rectangle 9"/>
-          <p:cNvSpPr/>
-          <p:nvPr/>
-        </p:nvSpPr>
-        <p:spPr>
-          <a:xfrm>
-            <a:off x="548640" y="3337560"/>
-            <a:ext cx="1600200" cy="292608"/>
-          </a:xfrm>
-          <a:prstGeom prst="roundRect">
-            <a:avLst>
-              <a:gd name="adj" fmla="val 50000"/>
-            </a:avLst>
-          </a:prstGeom>
-          <a:solidFill>
-            <a:srgbClr val="1A1F2B"/>
-          </a:solidFill>
-          <a:ln w="12700">
-            <a:solidFill>
-              <a:srgbClr val="EF6A5C"/>
-            </a:solidFill>
-          </a:ln>
-          <a:effectLst/>
-        </p:spPr>
-        <p:style>
-          <a:lnRef idx="1">
-            <a:schemeClr val="accent1"/>
-          </a:lnRef>
-          <a:fillRef idx="3">
-            <a:schemeClr val="accent1"/>
-          </a:fillRef>
-          <a:effectRef idx="2">
-            <a:schemeClr val="accent1"/>
-          </a:effectRef>
-          <a:fontRef idx="minor">
-            <a:schemeClr val="lt1"/>
-          </a:fontRef>
-        </p:style>
-        <p:txBody>
-          <a:bodyPr rtlCol="0" anchor="ctr" lIns="45720" rIns="45720"/>
-          <a:lstStyle/>
-          <a:p>
-            <a:pPr algn="ctr"/>
-            <a:r>
-              <a:rPr sz="950" b="1">
-                <a:solidFill>
-                  <a:srgbClr val="EF6A5C"/>
-                </a:solidFill>
-                <a:latin typeface="Noto Sans CJK KR"/>
-              </a:rPr>
-              <a:t>③ 예산 robust화</a:t>
-            </a:r>
-          </a:p>
-        </p:txBody>
-      </p:sp>
-      <p:sp>
-        <p:nvSpPr>
-          <p:cNvPr id="11" name="TextBox 10"/>
-          <p:cNvSpPr txBox="1"/>
-          <p:nvPr/>
-        </p:nvSpPr>
-        <p:spPr>
-          <a:xfrm>
-            <a:off x="2331720" y="3310128"/>
-            <a:ext cx="9311335" cy="457200"/>
-          </a:xfrm>
-          <a:prstGeom prst="rect">
-            <a:avLst/>
-          </a:prstGeom>
-          <a:noFill/>
-        </p:spPr>
-        <p:txBody>
-          <a:bodyPr wrap="square" anchor="ctr">
-            <a:spAutoFit/>
-          </a:bodyPr>
-          <a:lstStyle/>
-          <a:p>
-            <a:pPr algn="l">
-              <a:lnSpc>
-                <a:spcPct val="100000"/>
-              </a:lnSpc>
-            </a:pPr>
-            <a:r>
-              <a:rPr sz="1250" b="0">
-                <a:solidFill>
-                  <a:srgbClr val="E8ECF4"/>
-                </a:solidFill>
-                <a:latin typeface="Noto Sans CJK KR"/>
-              </a:rPr>
-              <a:t>tracking에 시간 캡을 걸 것인가, polish에 최소 하한을 보장할 것인가 — 1253+305+12F 세 장면 교차검증 필수(A2가 두 장면만 보고 실패한 패턴 반복 금지).</a:t>
-            </a:r>
-          </a:p>
-        </p:txBody>
-      </p:sp>
-      <p:sp>
-        <p:nvSpPr>
-          <p:cNvPr id="12" name="Rounded Rectangle 11"/>
-          <p:cNvSpPr/>
-          <p:nvPr/>
-        </p:nvSpPr>
-        <p:spPr>
-          <a:xfrm>
-            <a:off x="548640" y="4297680"/>
-            <a:ext cx="1600200" cy="292608"/>
-          </a:xfrm>
-          <a:prstGeom prst="roundRect">
-            <a:avLst>
-              <a:gd name="adj" fmla="val 50000"/>
-            </a:avLst>
-          </a:prstGeom>
-          <a:solidFill>
-            <a:srgbClr val="1A1F2B"/>
-          </a:solidFill>
-          <a:ln w="12700">
-            <a:solidFill>
-              <a:srgbClr val="B48CF0"/>
-            </a:solidFill>
-          </a:ln>
-          <a:effectLst/>
-        </p:spPr>
-        <p:style>
-          <a:lnRef idx="1">
-            <a:schemeClr val="accent1"/>
-          </a:lnRef>
-          <a:fillRef idx="3">
-            <a:schemeClr val="accent1"/>
-          </a:fillRef>
-          <a:effectRef idx="2">
-            <a:schemeClr val="accent1"/>
-          </a:effectRef>
-          <a:fontRef idx="minor">
-            <a:schemeClr val="lt1"/>
-          </a:fontRef>
-        </p:style>
-        <p:txBody>
-          <a:bodyPr rtlCol="0" anchor="ctr" lIns="45720" rIns="45720"/>
-          <a:lstStyle/>
-          <a:p>
-            <a:pPr algn="ctr"/>
-            <a:r>
-              <a:rPr sz="950" b="1">
-                <a:solidFill>
-                  <a:srgbClr val="B48CF0"/>
-                </a:solidFill>
-                <a:latin typeface="Noto Sans CJK KR"/>
-              </a:rPr>
-              <a:t>④ FREEZE 스케줄</a:t>
-            </a:r>
-          </a:p>
-        </p:txBody>
-      </p:sp>
-      <p:sp>
-        <p:nvSpPr>
-          <p:cNvPr id="13" name="TextBox 12"/>
-          <p:cNvSpPr txBox="1"/>
-          <p:nvPr/>
-        </p:nvSpPr>
-        <p:spPr>
-          <a:xfrm>
-            <a:off x="2331720" y="4270248"/>
-            <a:ext cx="9311335" cy="457200"/>
-          </a:xfrm>
-          <a:prstGeom prst="rect">
-            <a:avLst/>
-          </a:prstGeom>
-          <a:noFill/>
-        </p:spPr>
-        <p:txBody>
-          <a:bodyPr wrap="square" anchor="ctr">
-            <a:spAutoFit/>
-          </a:bodyPr>
-          <a:lstStyle/>
-          <a:p>
-            <a:pPr algn="l">
-              <a:lnSpc>
-                <a:spcPct val="100000"/>
-              </a:lnSpc>
-            </a:pPr>
-            <a:r>
-              <a:rPr sz="1250" b="0">
-                <a:solidFill>
-                  <a:srgbClr val="E8ECF4"/>
-                </a:solidFill>
-                <a:latin typeface="Noto Sans CJK KR"/>
-              </a:rPr>
-              <a:t>①과 본질적으로 같은 문제. iteration/frame count가 아닌 기준(coverage 신호 등)으로 대체 — 지금 죽어있는 `transmittance` 계산이 후보 재료.</a:t>
-            </a:r>
-          </a:p>
-        </p:txBody>
-      </p:sp>
-      <p:sp>
-        <p:nvSpPr>
-          <p:cNvPr id="14" name="TextBox 13"/>
-          <p:cNvSpPr txBox="1"/>
-          <p:nvPr/>
-        </p:nvSpPr>
-        <p:spPr>
-          <a:xfrm>
-            <a:off x="548640" y="5394960"/>
-            <a:ext cx="11094415" cy="548640"/>
-          </a:xfrm>
-          <a:prstGeom prst="rect">
-            <a:avLst/>
-          </a:prstGeom>
-          <a:noFill/>
-        </p:spPr>
-        <p:txBody>
-          <a:bodyPr wrap="square" anchor="t">
-            <a:spAutoFit/>
-          </a:bodyPr>
-          <a:lstStyle/>
-          <a:p>
-            <a:pPr algn="l">
-              <a:lnSpc>
-                <a:spcPct val="100000"/>
-              </a:lnSpc>
-            </a:pPr>
-            <a:r>
-              <a:rPr sz="1200" b="1">
-                <a:solidFill>
-                  <a:srgbClr val="E8ECF4"/>
-                </a:solidFill>
-                <a:latin typeface="Noto Sans CJK KR"/>
-              </a:rPr>
-              <a:t>①④(freeze 기준)와 ③(예산 배분)은 사실 하나의 문제 — "제한된 실시간 예산을 구조 생성과 정제에 어떻게 나누는가". ②(carve)는 그 정제 단계의 품질을 결정한다.</a:t>
+              <a:rPr sz="1050">
+                <a:solidFill>
+                  <a:srgbClr val="8B95AB"/>
+                </a:solidFill>
+                <a:latin typeface="Noto Sans CJK KR"/>
+              </a:rPr>
+              <a:t>polish 3.0 상태</a:t>
             </a:r>
           </a:p>
         </p:txBody>
@@ -4930,7 +4742,7 @@
                 </a:solidFill>
                 <a:latin typeface="Noto Sans CJK KR"/>
               </a:rPr>
-              <a:t>ROADMAP · PROGRESS</a:t>
+              <a:t>MEASURED · STEP 4</a:t>
             </a:r>
           </a:p>
         </p:txBody>
@@ -4969,7 +4781,7 @@
                 </a:solidFill>
                 <a:latin typeface="Noto Sans CJK KR"/>
               </a:rPr>
-              <a:t>계획했던 4단계 중 어디까지 왔나</a:t>
+              <a:t>실측 결과 ⑤ — polish 횟수가 "계단식"으로 보였던 진짜 이유</a:t>
             </a:r>
           </a:p>
         </p:txBody>
@@ -5020,7 +4832,7 @@
       </p:sp>
       <p:pic>
         <p:nvPicPr>
-          <p:cNvPr id="6" name="Picture 5" descr="fig_next_steps.png"/>
+          <p:cNvPr id="6" name="Picture 5" descr="fig_gap_quantization.png"/>
           <p:cNvPicPr>
             <a:picLocks noChangeAspect="1"/>
           </p:cNvPicPr>
@@ -5034,8 +4846,8 @@
         </p:blipFill>
         <p:spPr>
           <a:xfrm>
-            <a:off x="3004490" y="1371600"/>
-            <a:ext cx="6182713" cy="2651760"/>
+            <a:off x="2587378" y="1280160"/>
+            <a:ext cx="7016937" cy="3794760"/>
           </a:xfrm>
           <a:prstGeom prst="rect">
             <a:avLst/>
@@ -5044,71 +4856,14 @@
       </p:pic>
       <p:sp>
         <p:nvSpPr>
-          <p:cNvPr id="7" name="Rounded Rectangle 6"/>
-          <p:cNvSpPr/>
-          <p:nvPr/>
-        </p:nvSpPr>
-        <p:spPr>
-          <a:xfrm>
-            <a:off x="548640" y="4297680"/>
-            <a:ext cx="1600200" cy="292608"/>
-          </a:xfrm>
-          <a:prstGeom prst="roundRect">
-            <a:avLst>
-              <a:gd name="adj" fmla="val 50000"/>
-            </a:avLst>
-          </a:prstGeom>
-          <a:solidFill>
-            <a:srgbClr val="1A1F2B"/>
-          </a:solidFill>
-          <a:ln w="12700">
-            <a:solidFill>
-              <a:srgbClr val="5FD68A"/>
-            </a:solidFill>
-          </a:ln>
-          <a:effectLst/>
-        </p:spPr>
-        <p:style>
-          <a:lnRef idx="1">
-            <a:schemeClr val="accent1"/>
-          </a:lnRef>
-          <a:fillRef idx="3">
-            <a:schemeClr val="accent1"/>
-          </a:fillRef>
-          <a:effectRef idx="2">
-            <a:schemeClr val="accent1"/>
-          </a:effectRef>
-          <a:fontRef idx="minor">
-            <a:schemeClr val="lt1"/>
-          </a:fontRef>
-        </p:style>
-        <p:txBody>
-          <a:bodyPr rtlCol="0" anchor="ctr" lIns="45720" rIns="45720"/>
-          <a:lstStyle/>
-          <a:p>
-            <a:pPr algn="ctr"/>
-            <a:r>
-              <a:rPr sz="950" b="1">
-                <a:solidFill>
-                  <a:srgbClr val="5FD68A"/>
-                </a:solidFill>
-                <a:latin typeface="Noto Sans CJK KR"/>
-              </a:rPr>
-              <a:t>STEP 1 완료</a:t>
-            </a:r>
-          </a:p>
-        </p:txBody>
-      </p:sp>
-      <p:sp>
-        <p:nvSpPr>
-          <p:cNvPr id="8" name="TextBox 7"/>
+          <p:cNvPr id="7" name="TextBox 6"/>
           <p:cNvSpPr txBox="1"/>
           <p:nvPr/>
         </p:nvSpPr>
         <p:spPr>
           <a:xfrm>
-            <a:off x="2331720" y="4270248"/>
-            <a:ext cx="9311335" cy="457200"/>
+            <a:off x="548640" y="5349240"/>
+            <a:ext cx="11094415" cy="1005840"/>
           </a:xfrm>
           <a:prstGeom prst="rect">
             <a:avLst/>
@@ -5116,312 +4871,24 @@
           <a:noFill/>
         </p:spPr>
         <p:txBody>
-          <a:bodyPr wrap="square" anchor="ctr">
+          <a:bodyPr wrap="square" anchor="t">
             <a:spAutoFit/>
           </a:bodyPr>
           <a:lstStyle/>
           <a:p>
             <a:pPr algn="l">
               <a:lnSpc>
-                <a:spcPct val="100000"/>
+                <a:spcPct val="125000"/>
               </a:lnSpc>
             </a:pPr>
             <a:r>
-              <a:rPr sz="1250" b="0">
-                <a:solidFill>
-                  <a:srgbClr val="E8ECF4"/>
-                </a:solidFill>
-                <a:latin typeface="Noto Sans CJK KR"/>
-              </a:rPr>
-              <a:t>A2 전/후 × 12F/305 4개 조합을 `VIGS_TIMING_LOG` 켜서 재실행·재분석 완료 — frontend 73.4%/64.0%, polish 5,683/822/9,866회 등 실측 확보.</a:t>
-            </a:r>
-          </a:p>
-        </p:txBody>
-      </p:sp>
-      <p:sp>
-        <p:nvSpPr>
-          <p:cNvPr id="9" name="Rounded Rectangle 8"/>
-          <p:cNvSpPr/>
-          <p:nvPr/>
-        </p:nvSpPr>
-        <p:spPr>
-          <a:xfrm>
-            <a:off x="548640" y="4828032"/>
-            <a:ext cx="1600200" cy="292608"/>
-          </a:xfrm>
-          <a:prstGeom prst="roundRect">
-            <a:avLst>
-              <a:gd name="adj" fmla="val 50000"/>
-            </a:avLst>
-          </a:prstGeom>
-          <a:solidFill>
-            <a:srgbClr val="1A1F2B"/>
-          </a:solidFill>
-          <a:ln w="12700">
-            <a:solidFill>
-              <a:srgbClr val="5FD68A"/>
-            </a:solidFill>
-          </a:ln>
-          <a:effectLst/>
-        </p:spPr>
-        <p:style>
-          <a:lnRef idx="1">
-            <a:schemeClr val="accent1"/>
-          </a:lnRef>
-          <a:fillRef idx="3">
-            <a:schemeClr val="accent1"/>
-          </a:fillRef>
-          <a:effectRef idx="2">
-            <a:schemeClr val="accent1"/>
-          </a:effectRef>
-          <a:fontRef idx="minor">
-            <a:schemeClr val="lt1"/>
-          </a:fontRef>
-        </p:style>
-        <p:txBody>
-          <a:bodyPr rtlCol="0" anchor="ctr" lIns="45720" rIns="45720"/>
-          <a:lstStyle/>
-          <a:p>
-            <a:pPr algn="ctr"/>
-            <a:r>
-              <a:rPr sz="950" b="1">
-                <a:solidFill>
-                  <a:srgbClr val="5FD68A"/>
-                </a:solidFill>
-                <a:latin typeface="Noto Sans CJK KR"/>
-              </a:rPr>
-              <a:t>STEP 2 완료</a:t>
-            </a:r>
-          </a:p>
-        </p:txBody>
-      </p:sp>
-      <p:sp>
-        <p:nvSpPr>
-          <p:cNvPr id="10" name="TextBox 9"/>
-          <p:cNvSpPr txBox="1"/>
-          <p:nvPr/>
-        </p:nvSpPr>
-        <p:spPr>
-          <a:xfrm>
-            <a:off x="2331720" y="4800600"/>
-            <a:ext cx="9311335" cy="457200"/>
-          </a:xfrm>
-          <a:prstGeom prst="rect">
-            <a:avLst/>
-          </a:prstGeom>
-          <a:noFill/>
-        </p:spPr>
-        <p:txBody>
-          <a:bodyPr wrap="square" anchor="ctr">
-            <a:spAutoFit/>
-          </a:bodyPr>
-          <a:lstStyle/>
-          <a:p>
-            <a:pPr algn="l">
-              <a:lnSpc>
-                <a:spcPct val="100000"/>
-              </a:lnSpc>
-            </a:pPr>
-            <a:r>
-              <a:rPr sz="1250" b="0">
-                <a:solidFill>
-                  <a:srgbClr val="E8ECF4"/>
-                </a:solidFill>
-                <a:latin typeface="Noto Sans CJK KR"/>
-              </a:rPr>
-              <a:t>`background_polish_step`에 `_Sect` 계측 추가 완료 — call당 3.9~6.4ms, n_gauss 의존성 약함(주 원인 아님) 확정.</a:t>
-            </a:r>
-          </a:p>
-        </p:txBody>
-      </p:sp>
-      <p:sp>
-        <p:nvSpPr>
-          <p:cNvPr id="11" name="Rounded Rectangle 10"/>
-          <p:cNvSpPr/>
-          <p:nvPr/>
-        </p:nvSpPr>
-        <p:spPr>
-          <a:xfrm>
-            <a:off x="548640" y="5358384"/>
-            <a:ext cx="1600200" cy="292608"/>
-          </a:xfrm>
-          <a:prstGeom prst="roundRect">
-            <a:avLst>
-              <a:gd name="adj" fmla="val 50000"/>
-            </a:avLst>
-          </a:prstGeom>
-          <a:solidFill>
-            <a:srgbClr val="1A1F2B"/>
-          </a:solidFill>
-          <a:ln w="12700">
-            <a:solidFill>
-              <a:srgbClr val="8B95AB"/>
-            </a:solidFill>
-          </a:ln>
-          <a:effectLst/>
-        </p:spPr>
-        <p:style>
-          <a:lnRef idx="1">
-            <a:schemeClr val="accent1"/>
-          </a:lnRef>
-          <a:fillRef idx="3">
-            <a:schemeClr val="accent1"/>
-          </a:fillRef>
-          <a:effectRef idx="2">
-            <a:schemeClr val="accent1"/>
-          </a:effectRef>
-          <a:fontRef idx="minor">
-            <a:schemeClr val="lt1"/>
-          </a:fontRef>
-        </p:style>
-        <p:txBody>
-          <a:bodyPr rtlCol="0" anchor="ctr" lIns="45720" rIns="45720"/>
-          <a:lstStyle/>
-          <a:p>
-            <a:pPr algn="ctr"/>
-            <a:r>
-              <a:rPr sz="950" b="1">
+              <a:rPr sz="1200" b="0">
                 <a:solidFill>
                   <a:srgbClr val="8B95AB"/>
                 </a:solidFill>
                 <a:latin typeface="Noto Sans CJK KR"/>
               </a:rPr>
-              <a:t>STEP 3 보류</a:t>
-            </a:r>
-          </a:p>
-        </p:txBody>
-      </p:sp>
-      <p:sp>
-        <p:nvSpPr>
-          <p:cNvPr id="12" name="TextBox 11"/>
-          <p:cNvSpPr txBox="1"/>
-          <p:nvPr/>
-        </p:nvSpPr>
-        <p:spPr>
-          <a:xfrm>
-            <a:off x="2331720" y="5330952"/>
-            <a:ext cx="9311335" cy="457200"/>
-          </a:xfrm>
-          <a:prstGeom prst="rect">
-            <a:avLst/>
-          </a:prstGeom>
-          <a:noFill/>
-        </p:spPr>
-        <p:txBody>
-          <a:bodyPr wrap="square" anchor="ctr">
-            <a:spAutoFit/>
-          </a:bodyPr>
-          <a:lstStyle/>
-          <a:p>
-            <a:pPr algn="l">
-              <a:lnSpc>
-                <a:spcPct val="100000"/>
-              </a:lnSpc>
-            </a:pPr>
-            <a:r>
-              <a:rPr sz="1250" b="0">
-                <a:solidFill>
-                  <a:srgbClr val="E8ECF4"/>
-                </a:solidFill>
-                <a:latin typeface="Noto Sans CJK KR"/>
-              </a:rPr>
-              <a:t>시간축 병합 타임라인 재구성 — 이번엔 phase별 총합/스케일링으로 핵심 질문에 이미 답이 나와서 우선순위 낮춤. `get_lock()` 경합의 직접 증거는 아직 없음.</a:t>
-            </a:r>
-          </a:p>
-        </p:txBody>
-      </p:sp>
-      <p:sp>
-        <p:nvSpPr>
-          <p:cNvPr id="13" name="Rounded Rectangle 12"/>
-          <p:cNvSpPr/>
-          <p:nvPr/>
-        </p:nvSpPr>
-        <p:spPr>
-          <a:xfrm>
-            <a:off x="548640" y="5888736"/>
-            <a:ext cx="1600200" cy="292608"/>
-          </a:xfrm>
-          <a:prstGeom prst="roundRect">
-            <a:avLst>
-              <a:gd name="adj" fmla="val 50000"/>
-            </a:avLst>
-          </a:prstGeom>
-          <a:solidFill>
-            <a:srgbClr val="1A1F2B"/>
-          </a:solidFill>
-          <a:ln w="12700">
-            <a:solidFill>
-              <a:srgbClr val="5FD68A"/>
-            </a:solidFill>
-          </a:ln>
-          <a:effectLst/>
-        </p:spPr>
-        <p:style>
-          <a:lnRef idx="1">
-            <a:schemeClr val="accent1"/>
-          </a:lnRef>
-          <a:fillRef idx="3">
-            <a:schemeClr val="accent1"/>
-          </a:fillRef>
-          <a:effectRef idx="2">
-            <a:schemeClr val="accent1"/>
-          </a:effectRef>
-          <a:fontRef idx="minor">
-            <a:schemeClr val="lt1"/>
-          </a:fontRef>
-        </p:style>
-        <p:txBody>
-          <a:bodyPr rtlCol="0" anchor="ctr" lIns="45720" rIns="45720"/>
-          <a:lstStyle/>
-          <a:p>
-            <a:pPr algn="ctr"/>
-            <a:r>
-              <a:rPr sz="950" b="1">
-                <a:solidFill>
-                  <a:srgbClr val="5FD68A"/>
-                </a:solidFill>
-                <a:latin typeface="Noto Sans CJK KR"/>
-              </a:rPr>
-              <a:t>STEP 4 완료</a:t>
-            </a:r>
-          </a:p>
-        </p:txBody>
-      </p:sp>
-      <p:sp>
-        <p:nvSpPr>
-          <p:cNvPr id="14" name="TextBox 13"/>
-          <p:cNvSpPr txBox="1"/>
-          <p:nvPr/>
-        </p:nvSpPr>
-        <p:spPr>
-          <a:xfrm>
-            <a:off x="2331720" y="5861304"/>
-            <a:ext cx="9311335" cy="457200"/>
-          </a:xfrm>
-          <a:prstGeom prst="rect">
-            <a:avLst/>
-          </a:prstGeom>
-          <a:noFill/>
-        </p:spPr>
-        <p:txBody>
-          <a:bodyPr wrap="square" anchor="ctr">
-            <a:spAutoFit/>
-          </a:bodyPr>
-          <a:lstStyle/>
-          <a:p>
-            <a:pPr algn="l">
-              <a:lnSpc>
-                <a:spcPct val="100000"/>
-              </a:lnSpc>
-            </a:pPr>
-            <a:r>
-              <a:rPr sz="1250" b="0">
-                <a:solidFill>
-                  <a:srgbClr val="E8ECF4"/>
-                </a:solidFill>
-                <a:latin typeface="Noto Sans CJK KR"/>
-              </a:rPr>
-              <a:t>파라미터 스윕 — iters1 1↔2 한 쌍(×2.17) + `replay_time_scale` 1.5/2.0/3.0 3점 스윕(23.84/28.10/25.97dB, 역-U자형) 확보. gap 기반 양자화 메커니즘도 규명 완료. 3.0 역행의 근본원인(과적합 가설)만 미검증으로 남음.</a:t>
+              <a:t>gs_worker_dispatch/background_polish_call에 epoch 타임스탬프를 추가해 디스패치 사이 gap을 직접 재구성했다. 총 polish 횟수는 각 gap 길이를 step당 비용(4~6ms)으로 나눈 정수 몫의 합 — gap의 43~57%는 아예 1개도 못 낄 만큼 짧아 "부드러운 비례"가 아니라 본질적으로 계단식이다. scale이 커질수록 긴 gap(최대 526→1582→2478ms)이 늘어나며 총량이 늘지만, 3.0의 역행은 이 메커니즘만으론 설명 안 됨 — 좁은 후보 풀(stride-5 rgb_dense) 과적합 가설 필요(미검증).</a:t>
             </a:r>
           </a:p>
         </p:txBody>
@@ -5522,6 +4989,1699 @@
                 </a:solidFill>
                 <a:latin typeface="Noto Sans CJK KR"/>
               </a:rPr>
+              <a:t>MEASURED · FREEZE</a:t>
+            </a:r>
+          </a:p>
+        </p:txBody>
+      </p:sp>
+      <p:sp>
+        <p:nvSpPr>
+          <p:cNvPr id="4" name="TextBox 3"/>
+          <p:cNvSpPr txBox="1"/>
+          <p:nvPr/>
+        </p:nvSpPr>
+        <p:spPr>
+          <a:xfrm>
+            <a:off x="548640" y="566928"/>
+            <a:ext cx="11094415" cy="548640"/>
+          </a:xfrm>
+          <a:prstGeom prst="rect">
+            <a:avLst/>
+          </a:prstGeom>
+          <a:noFill/>
+        </p:spPr>
+        <p:txBody>
+          <a:bodyPr wrap="square" anchor="t">
+            <a:spAutoFit/>
+          </a:bodyPr>
+          <a:lstStyle/>
+          <a:p>
+            <a:pPr algn="l">
+              <a:lnSpc>
+                <a:spcPct val="100000"/>
+              </a:lnSpc>
+            </a:pPr>
+            <a:r>
+              <a:rPr sz="2200" b="1">
+                <a:solidFill>
+                  <a:srgbClr val="E8ECF4"/>
+                </a:solidFill>
+                <a:latin typeface="Noto Sans CJK KR"/>
+              </a:rPr>
+              <a:t>map() freeze 시점 3지점 실측 — 두 극단 모두 기각</a:t>
+            </a:r>
+          </a:p>
+        </p:txBody>
+      </p:sp>
+      <p:sp>
+        <p:nvSpPr>
+          <p:cNvPr id="5" name="Rectangle 4"/>
+          <p:cNvSpPr/>
+          <p:nvPr/>
+        </p:nvSpPr>
+        <p:spPr>
+          <a:xfrm>
+            <a:off x="548640" y="1078992"/>
+            <a:ext cx="11094415" cy="25400"/>
+          </a:xfrm>
+          <a:prstGeom prst="rect">
+            <a:avLst/>
+          </a:prstGeom>
+          <a:solidFill>
+            <a:srgbClr val="2A3242"/>
+          </a:solidFill>
+          <a:ln>
+            <a:noFill/>
+          </a:ln>
+          <a:effectLst/>
+        </p:spPr>
+        <p:style>
+          <a:lnRef idx="1">
+            <a:schemeClr val="accent1"/>
+          </a:lnRef>
+          <a:fillRef idx="3">
+            <a:schemeClr val="accent1"/>
+          </a:fillRef>
+          <a:effectRef idx="2">
+            <a:schemeClr val="accent1"/>
+          </a:effectRef>
+          <a:fontRef idx="minor">
+            <a:schemeClr val="lt1"/>
+          </a:fontRef>
+        </p:style>
+        <p:txBody>
+          <a:bodyPr rtlCol="0" anchor="ctr"/>
+          <a:lstStyle/>
+          <a:p>
+            <a:pPr algn="ctr"/>
+          </a:p>
+        </p:txBody>
+      </p:sp>
+      <p:pic>
+        <p:nvPicPr>
+          <p:cNvPr id="6" name="Picture 5" descr="fig_freeze_spectrum.png"/>
+          <p:cNvPicPr>
+            <a:picLocks noChangeAspect="1"/>
+          </p:cNvPicPr>
+          <p:nvPr/>
+        </p:nvPicPr>
+        <p:blipFill>
+          <a:blip r:embed="rId2"/>
+          <a:stretch>
+            <a:fillRect/>
+          </a:stretch>
+        </p:blipFill>
+        <p:spPr>
+          <a:xfrm>
+            <a:off x="2737967" y="1234440"/>
+            <a:ext cx="6715760" cy="4297680"/>
+          </a:xfrm>
+          <a:prstGeom prst="rect">
+            <a:avLst/>
+          </a:prstGeom>
+        </p:spPr>
+      </p:pic>
+      <p:sp>
+        <p:nvSpPr>
+          <p:cNvPr id="7" name="TextBox 6"/>
+          <p:cNvSpPr txBox="1"/>
+          <p:nvPr/>
+        </p:nvSpPr>
+        <p:spPr>
+          <a:xfrm>
+            <a:off x="548640" y="5715000"/>
+            <a:ext cx="11094415" cy="777240"/>
+          </a:xfrm>
+          <a:prstGeom prst="rect">
+            <a:avLst/>
+          </a:prstGeom>
+          <a:noFill/>
+        </p:spPr>
+        <p:txBody>
+          <a:bodyPr wrap="square" anchor="t">
+            <a:spAutoFit/>
+          </a:bodyPr>
+          <a:lstStyle/>
+          <a:p>
+            <a:pPr algn="l">
+              <a:lnSpc>
+                <a:spcPct val="125000"/>
+              </a:lnSpc>
+            </a:pPr>
+            <a:r>
+              <a:rPr sz="1150" b="0">
+                <a:solidFill>
+                  <a:srgbClr val="8B95AB"/>
+                </a:solidFill>
+                <a:latin typeface="Noto Sans CJK KR"/>
+              </a:rPr>
+              <a:t>즉시 freeze(19.35dB)와 never freeze(24.90dB, 12F OOM) 둘 다 A2가 채택한 61% 지점(29.82dB)보다 나쁘다 — A2의 freeze 시점은 이미 근처 최적이며, 12F OOM은 "절대 freeze 안 함" 극단에서만 발생해 이미 기각된 조합이라 현재 채택 레시피엔 존재하지 않는다.</a:t>
+            </a:r>
+          </a:p>
+        </p:txBody>
+      </p:sp>
+    </p:spTree>
+  </p:cSld>
+  <p:clrMapOvr>
+    <a:masterClrMapping/>
+  </p:clrMapOvr>
+</p:sld>
+</file>
+
+<file path=ppt/slides/slide16.xml><?xml version="1.0" encoding="utf-8"?>
+<p:sld xmlns:a="http://schemas.openxmlformats.org/drawingml/2006/main" xmlns:p="http://schemas.openxmlformats.org/presentationml/2006/main" xmlns:r="http://schemas.openxmlformats.org/officeDocument/2006/relationships">
+  <p:cSld>
+    <p:spTree>
+      <p:nvGrpSpPr>
+        <p:cNvPr id="1" name=""/>
+        <p:cNvGrpSpPr/>
+        <p:nvPr/>
+      </p:nvGrpSpPr>
+      <p:grpSpPr/>
+      <p:sp>
+        <p:nvSpPr>
+          <p:cNvPr id="2" name="Rectangle 1"/>
+          <p:cNvSpPr/>
+          <p:nvPr/>
+        </p:nvSpPr>
+        <p:spPr>
+          <a:xfrm>
+            <a:off x="0" y="0"/>
+            <a:ext cx="12191695" cy="6858000"/>
+          </a:xfrm>
+          <a:prstGeom prst="rect">
+            <a:avLst/>
+          </a:prstGeom>
+          <a:solidFill>
+            <a:srgbClr val="12151C"/>
+          </a:solidFill>
+          <a:ln>
+            <a:noFill/>
+          </a:ln>
+          <a:effectLst/>
+        </p:spPr>
+        <p:style>
+          <a:lnRef idx="1">
+            <a:schemeClr val="accent1"/>
+          </a:lnRef>
+          <a:fillRef idx="3">
+            <a:schemeClr val="accent1"/>
+          </a:fillRef>
+          <a:effectRef idx="2">
+            <a:schemeClr val="accent1"/>
+          </a:effectRef>
+          <a:fontRef idx="minor">
+            <a:schemeClr val="lt1"/>
+          </a:fontRef>
+        </p:style>
+        <p:txBody>
+          <a:bodyPr rtlCol="0" anchor="ctr"/>
+          <a:lstStyle/>
+          <a:p>
+            <a:pPr algn="ctr"/>
+          </a:p>
+        </p:txBody>
+      </p:sp>
+      <p:sp>
+        <p:nvSpPr>
+          <p:cNvPr id="3" name="TextBox 2"/>
+          <p:cNvSpPr txBox="1"/>
+          <p:nvPr/>
+        </p:nvSpPr>
+        <p:spPr>
+          <a:xfrm>
+            <a:off x="548640" y="320040"/>
+            <a:ext cx="11094415" cy="292608"/>
+          </a:xfrm>
+          <a:prstGeom prst="rect">
+            <a:avLst/>
+          </a:prstGeom>
+          <a:noFill/>
+        </p:spPr>
+        <p:txBody>
+          <a:bodyPr wrap="square" anchor="t">
+            <a:spAutoFit/>
+          </a:bodyPr>
+          <a:lstStyle/>
+          <a:p>
+            <a:pPr algn="l">
+              <a:lnSpc>
+                <a:spcPct val="100000"/>
+              </a:lnSpc>
+            </a:pPr>
+            <a:r>
+              <a:rPr sz="1200" b="1">
+                <a:solidFill>
+                  <a:srgbClr val="FFB454"/>
+                </a:solidFill>
+                <a:latin typeface="Noto Sans CJK KR"/>
+              </a:rPr>
+              <a:t>MEASURED · FREEZE</a:t>
+            </a:r>
+          </a:p>
+        </p:txBody>
+      </p:sp>
+      <p:sp>
+        <p:nvSpPr>
+          <p:cNvPr id="4" name="TextBox 3"/>
+          <p:cNvSpPr txBox="1"/>
+          <p:nvPr/>
+        </p:nvSpPr>
+        <p:spPr>
+          <a:xfrm>
+            <a:off x="548640" y="566928"/>
+            <a:ext cx="11094415" cy="548640"/>
+          </a:xfrm>
+          <a:prstGeom prst="rect">
+            <a:avLst/>
+          </a:prstGeom>
+          <a:noFill/>
+        </p:spPr>
+        <p:txBody>
+          <a:bodyPr wrap="square" anchor="t">
+            <a:spAutoFit/>
+          </a:bodyPr>
+          <a:lstStyle/>
+          <a:p>
+            <a:pPr algn="l">
+              <a:lnSpc>
+                <a:spcPct val="100000"/>
+              </a:lnSpc>
+            </a:pPr>
+            <a:r>
+              <a:rPr sz="2200" b="1">
+                <a:solidFill>
+                  <a:srgbClr val="E8ECF4"/>
+                </a:solidFill>
+                <a:latin typeface="Noto Sans CJK KR"/>
+              </a:rPr>
+              <a:t>freeze가 실제로 막는 것 — 메모리 폭주, 그리고 예산 분배</a:t>
+            </a:r>
+          </a:p>
+        </p:txBody>
+      </p:sp>
+      <p:sp>
+        <p:nvSpPr>
+          <p:cNvPr id="5" name="Rectangle 4"/>
+          <p:cNvSpPr/>
+          <p:nvPr/>
+        </p:nvSpPr>
+        <p:spPr>
+          <a:xfrm>
+            <a:off x="548640" y="1078992"/>
+            <a:ext cx="11094415" cy="25400"/>
+          </a:xfrm>
+          <a:prstGeom prst="rect">
+            <a:avLst/>
+          </a:prstGeom>
+          <a:solidFill>
+            <a:srgbClr val="2A3242"/>
+          </a:solidFill>
+          <a:ln>
+            <a:noFill/>
+          </a:ln>
+          <a:effectLst/>
+        </p:spPr>
+        <p:style>
+          <a:lnRef idx="1">
+            <a:schemeClr val="accent1"/>
+          </a:lnRef>
+          <a:fillRef idx="3">
+            <a:schemeClr val="accent1"/>
+          </a:fillRef>
+          <a:effectRef idx="2">
+            <a:schemeClr val="accent1"/>
+          </a:effectRef>
+          <a:fontRef idx="minor">
+            <a:schemeClr val="lt1"/>
+          </a:fontRef>
+        </p:style>
+        <p:txBody>
+          <a:bodyPr rtlCol="0" anchor="ctr"/>
+          <a:lstStyle/>
+          <a:p>
+            <a:pPr algn="ctr"/>
+          </a:p>
+        </p:txBody>
+      </p:sp>
+      <p:pic>
+        <p:nvPicPr>
+          <p:cNvPr id="6" name="Picture 5" descr="fig_freeze_mechanism.png"/>
+          <p:cNvPicPr>
+            <a:picLocks noChangeAspect="1"/>
+          </p:cNvPicPr>
+          <p:nvPr/>
+        </p:nvPicPr>
+        <p:blipFill>
+          <a:blip r:embed="rId2"/>
+          <a:stretch>
+            <a:fillRect/>
+          </a:stretch>
+        </p:blipFill>
+        <p:spPr>
+          <a:xfrm>
+            <a:off x="778299" y="1234440"/>
+            <a:ext cx="10635095" cy="5257800"/>
+          </a:xfrm>
+          <a:prstGeom prst="rect">
+            <a:avLst/>
+          </a:prstGeom>
+        </p:spPr>
+      </p:pic>
+      <p:sp>
+        <p:nvSpPr>
+          <p:cNvPr id="7" name="TextBox 6"/>
+          <p:cNvSpPr txBox="1"/>
+          <p:nvPr/>
+        </p:nvSpPr>
+        <p:spPr>
+          <a:xfrm>
+            <a:off x="548640" y="6537960"/>
+            <a:ext cx="11094415" cy="274320"/>
+          </a:xfrm>
+          <a:prstGeom prst="rect">
+            <a:avLst/>
+          </a:prstGeom>
+          <a:noFill/>
+        </p:spPr>
+        <p:txBody>
+          <a:bodyPr wrap="square" anchor="t">
+            <a:spAutoFit/>
+          </a:bodyPr>
+          <a:lstStyle/>
+          <a:p>
+            <a:pPr algn="l">
+              <a:lnSpc>
+                <a:spcPct val="120000"/>
+              </a:lnSpc>
+            </a:pPr>
+            <a:r>
+              <a:rPr sz="1100" b="0">
+                <a:solidFill>
+                  <a:srgbClr val="8B95AB"/>
+                </a:solidFill>
+                <a:latin typeface="Noto Sans CJK KR"/>
+              </a:rPr>
+              <a:t>지금 freeze 지점(`mapping_freeze_after_frac`)은 1253/305 튜닝값(0.6140) 고정 비율일 뿐 원리적 근거는 없다 — 다음 방향 ①/④(freeze 기준 재정립)가 이걸 대체할 신호를 찾는 일.</a:t>
+            </a:r>
+          </a:p>
+        </p:txBody>
+      </p:sp>
+    </p:spTree>
+  </p:cSld>
+  <p:clrMapOvr>
+    <a:masterClrMapping/>
+  </p:clrMapOvr>
+</p:sld>
+</file>
+
+<file path=ppt/slides/slide17.xml><?xml version="1.0" encoding="utf-8"?>
+<p:sld xmlns:a="http://schemas.openxmlformats.org/drawingml/2006/main" xmlns:p="http://schemas.openxmlformats.org/presentationml/2006/main" xmlns:r="http://schemas.openxmlformats.org/officeDocument/2006/relationships">
+  <p:cSld>
+    <p:spTree>
+      <p:nvGrpSpPr>
+        <p:cNvPr id="1" name=""/>
+        <p:cNvGrpSpPr/>
+        <p:nvPr/>
+      </p:nvGrpSpPr>
+      <p:grpSpPr/>
+      <p:sp>
+        <p:nvSpPr>
+          <p:cNvPr id="2" name="Rectangle 1"/>
+          <p:cNvSpPr/>
+          <p:nvPr/>
+        </p:nvSpPr>
+        <p:spPr>
+          <a:xfrm>
+            <a:off x="0" y="0"/>
+            <a:ext cx="12191695" cy="6858000"/>
+          </a:xfrm>
+          <a:prstGeom prst="rect">
+            <a:avLst/>
+          </a:prstGeom>
+          <a:solidFill>
+            <a:srgbClr val="12151C"/>
+          </a:solidFill>
+          <a:ln>
+            <a:noFill/>
+          </a:ln>
+          <a:effectLst/>
+        </p:spPr>
+        <p:style>
+          <a:lnRef idx="1">
+            <a:schemeClr val="accent1"/>
+          </a:lnRef>
+          <a:fillRef idx="3">
+            <a:schemeClr val="accent1"/>
+          </a:fillRef>
+          <a:effectRef idx="2">
+            <a:schemeClr val="accent1"/>
+          </a:effectRef>
+          <a:fontRef idx="minor">
+            <a:schemeClr val="lt1"/>
+          </a:fontRef>
+        </p:style>
+        <p:txBody>
+          <a:bodyPr rtlCol="0" anchor="ctr"/>
+          <a:lstStyle/>
+          <a:p>
+            <a:pPr algn="ctr"/>
+          </a:p>
+        </p:txBody>
+      </p:sp>
+      <p:sp>
+        <p:nvSpPr>
+          <p:cNvPr id="3" name="TextBox 2"/>
+          <p:cNvSpPr txBox="1"/>
+          <p:nvPr/>
+        </p:nvSpPr>
+        <p:spPr>
+          <a:xfrm>
+            <a:off x="548640" y="320040"/>
+            <a:ext cx="11094415" cy="292608"/>
+          </a:xfrm>
+          <a:prstGeom prst="rect">
+            <a:avLst/>
+          </a:prstGeom>
+          <a:noFill/>
+        </p:spPr>
+        <p:txBody>
+          <a:bodyPr wrap="square" anchor="t">
+            <a:spAutoFit/>
+          </a:bodyPr>
+          <a:lstStyle/>
+          <a:p>
+            <a:pPr algn="l">
+              <a:lnSpc>
+                <a:spcPct val="100000"/>
+              </a:lnSpc>
+            </a:pPr>
+            <a:r>
+              <a:rPr sz="1200" b="1">
+                <a:solidFill>
+                  <a:srgbClr val="FFB454"/>
+                </a:solidFill>
+                <a:latin typeface="Noto Sans CJK KR"/>
+              </a:rPr>
+              <a:t>FOUR DIRECTIONS</a:t>
+            </a:r>
+          </a:p>
+        </p:txBody>
+      </p:sp>
+      <p:sp>
+        <p:nvSpPr>
+          <p:cNvPr id="4" name="TextBox 3"/>
+          <p:cNvSpPr txBox="1"/>
+          <p:nvPr/>
+        </p:nvSpPr>
+        <p:spPr>
+          <a:xfrm>
+            <a:off x="548640" y="566928"/>
+            <a:ext cx="11094415" cy="548640"/>
+          </a:xfrm>
+          <a:prstGeom prst="rect">
+            <a:avLst/>
+          </a:prstGeom>
+          <a:noFill/>
+        </p:spPr>
+        <p:txBody>
+          <a:bodyPr wrap="square" anchor="t">
+            <a:spAutoFit/>
+          </a:bodyPr>
+          <a:lstStyle/>
+          <a:p>
+            <a:pPr algn="l">
+              <a:lnSpc>
+                <a:spcPct val="100000"/>
+              </a:lnSpc>
+            </a:pPr>
+            <a:r>
+              <a:rPr sz="2200" b="1">
+                <a:solidFill>
+                  <a:srgbClr val="E8ECF4"/>
+                </a:solidFill>
+                <a:latin typeface="Noto Sans CJK KR"/>
+              </a:rPr>
+              <a:t>다음에 정해야 할 4가지 — 전부 같은 문제의 다른 얼굴</a:t>
+            </a:r>
+          </a:p>
+        </p:txBody>
+      </p:sp>
+      <p:sp>
+        <p:nvSpPr>
+          <p:cNvPr id="5" name="Rectangle 4"/>
+          <p:cNvSpPr/>
+          <p:nvPr/>
+        </p:nvSpPr>
+        <p:spPr>
+          <a:xfrm>
+            <a:off x="548640" y="1078992"/>
+            <a:ext cx="11094415" cy="25400"/>
+          </a:xfrm>
+          <a:prstGeom prst="rect">
+            <a:avLst/>
+          </a:prstGeom>
+          <a:solidFill>
+            <a:srgbClr val="2A3242"/>
+          </a:solidFill>
+          <a:ln>
+            <a:noFill/>
+          </a:ln>
+          <a:effectLst/>
+        </p:spPr>
+        <p:style>
+          <a:lnRef idx="1">
+            <a:schemeClr val="accent1"/>
+          </a:lnRef>
+          <a:fillRef idx="3">
+            <a:schemeClr val="accent1"/>
+          </a:fillRef>
+          <a:effectRef idx="2">
+            <a:schemeClr val="accent1"/>
+          </a:effectRef>
+          <a:fontRef idx="minor">
+            <a:schemeClr val="lt1"/>
+          </a:fontRef>
+        </p:style>
+        <p:txBody>
+          <a:bodyPr rtlCol="0" anchor="ctr"/>
+          <a:lstStyle/>
+          <a:p>
+            <a:pPr algn="ctr"/>
+          </a:p>
+        </p:txBody>
+      </p:sp>
+      <p:sp>
+        <p:nvSpPr>
+          <p:cNvPr id="6" name="Rounded Rectangle 5"/>
+          <p:cNvSpPr/>
+          <p:nvPr/>
+        </p:nvSpPr>
+        <p:spPr>
+          <a:xfrm>
+            <a:off x="548640" y="1417320"/>
+            <a:ext cx="1600200" cy="292608"/>
+          </a:xfrm>
+          <a:prstGeom prst="roundRect">
+            <a:avLst>
+              <a:gd name="adj" fmla="val 50000"/>
+            </a:avLst>
+          </a:prstGeom>
+          <a:solidFill>
+            <a:srgbClr val="1A1F2B"/>
+          </a:solidFill>
+          <a:ln w="12700">
+            <a:solidFill>
+              <a:srgbClr val="FFB454"/>
+            </a:solidFill>
+          </a:ln>
+          <a:effectLst/>
+        </p:spPr>
+        <p:style>
+          <a:lnRef idx="1">
+            <a:schemeClr val="accent1"/>
+          </a:lnRef>
+          <a:fillRef idx="3">
+            <a:schemeClr val="accent1"/>
+          </a:fillRef>
+          <a:effectRef idx="2">
+            <a:schemeClr val="accent1"/>
+          </a:effectRef>
+          <a:fontRef idx="minor">
+            <a:schemeClr val="lt1"/>
+          </a:fontRef>
+        </p:style>
+        <p:txBody>
+          <a:bodyPr rtlCol="0" anchor="ctr" lIns="45720" rIns="45720"/>
+          <a:lstStyle/>
+          <a:p>
+            <a:pPr algn="ctr"/>
+            <a:r>
+              <a:rPr sz="950" b="1">
+                <a:solidFill>
+                  <a:srgbClr val="FFB454"/>
+                </a:solidFill>
+                <a:latin typeface="Noto Sans CJK KR"/>
+              </a:rPr>
+              <a:t>① FREEZE 기준</a:t>
+            </a:r>
+          </a:p>
+        </p:txBody>
+      </p:sp>
+      <p:sp>
+        <p:nvSpPr>
+          <p:cNvPr id="7" name="TextBox 6"/>
+          <p:cNvSpPr txBox="1"/>
+          <p:nvPr/>
+        </p:nvSpPr>
+        <p:spPr>
+          <a:xfrm>
+            <a:off x="2331720" y="1389888"/>
+            <a:ext cx="9311335" cy="457200"/>
+          </a:xfrm>
+          <a:prstGeom prst="rect">
+            <a:avLst/>
+          </a:prstGeom>
+          <a:noFill/>
+        </p:spPr>
+        <p:txBody>
+          <a:bodyPr wrap="square" anchor="ctr">
+            <a:spAutoFit/>
+          </a:bodyPr>
+          <a:lstStyle/>
+          <a:p>
+            <a:pPr algn="l">
+              <a:lnSpc>
+                <a:spcPct val="100000"/>
+              </a:lnSpc>
+            </a:pPr>
+            <a:r>
+              <a:rPr sz="1250" b="0">
+                <a:solidFill>
+                  <a:srgbClr val="E8ECF4"/>
+                </a:solidFill>
+                <a:latin typeface="Noto Sans CJK KR"/>
+              </a:rPr>
+              <a:t>`mapping_freeze_after_frac` 고정 비율(0.6140)은 1253/305 튜닝값일 뿐 원리적 근거 없음 — 12F 회귀가 직접 반례. coverage/densify-rate/loss-plateau 중 robust한 기준 필요.</a:t>
+            </a:r>
+          </a:p>
+        </p:txBody>
+      </p:sp>
+      <p:sp>
+        <p:nvSpPr>
+          <p:cNvPr id="8" name="Rounded Rectangle 7"/>
+          <p:cNvSpPr/>
+          <p:nvPr/>
+        </p:nvSpPr>
+        <p:spPr>
+          <a:xfrm>
+            <a:off x="548640" y="2377440"/>
+            <a:ext cx="1600200" cy="292608"/>
+          </a:xfrm>
+          <a:prstGeom prst="roundRect">
+            <a:avLst>
+              <a:gd name="adj" fmla="val 50000"/>
+            </a:avLst>
+          </a:prstGeom>
+          <a:solidFill>
+            <a:srgbClr val="1A1F2B"/>
+          </a:solidFill>
+          <a:ln w="12700">
+            <a:solidFill>
+              <a:srgbClr val="4C86EA"/>
+            </a:solidFill>
+          </a:ln>
+          <a:effectLst/>
+        </p:spPr>
+        <p:style>
+          <a:lnRef idx="1">
+            <a:schemeClr val="accent1"/>
+          </a:lnRef>
+          <a:fillRef idx="3">
+            <a:schemeClr val="accent1"/>
+          </a:fillRef>
+          <a:effectRef idx="2">
+            <a:schemeClr val="accent1"/>
+          </a:effectRef>
+          <a:fontRef idx="minor">
+            <a:schemeClr val="lt1"/>
+          </a:fontRef>
+        </p:style>
+        <p:txBody>
+          <a:bodyPr rtlCol="0" anchor="ctr" lIns="45720" rIns="45720"/>
+          <a:lstStyle/>
+          <a:p>
+            <a:pPr algn="ctr"/>
+            <a:r>
+              <a:rPr sz="950" b="1">
+                <a:solidFill>
+                  <a:srgbClr val="4C86EA"/>
+                </a:solidFill>
+                <a:latin typeface="Noto Sans CJK KR"/>
+              </a:rPr>
+              <a:t>② CARVE LOSS 이식</a:t>
+            </a:r>
+          </a:p>
+        </p:txBody>
+      </p:sp>
+      <p:sp>
+        <p:nvSpPr>
+          <p:cNvPr id="9" name="TextBox 8"/>
+          <p:cNvSpPr txBox="1"/>
+          <p:nvPr/>
+        </p:nvSpPr>
+        <p:spPr>
+          <a:xfrm>
+            <a:off x="2331720" y="2350008"/>
+            <a:ext cx="9311335" cy="457200"/>
+          </a:xfrm>
+          <a:prstGeom prst="rect">
+            <a:avLst/>
+          </a:prstGeom>
+          <a:noFill/>
+        </p:spPr>
+        <p:txBody>
+          <a:bodyPr wrap="square" anchor="ctr">
+            <a:spAutoFit/>
+          </a:bodyPr>
+          <a:lstStyle/>
+          <a:p>
+            <a:pPr algn="l">
+              <a:lnSpc>
+                <a:spcPct val="100000"/>
+              </a:lnSpc>
+            </a:pPr>
+            <a:r>
+              <a:rPr sz="1250" b="0">
+                <a:solidFill>
+                  <a:srgbClr val="E8ECF4"/>
+                </a:solidFill>
+                <a:latin typeface="Noto Sans CJK KR"/>
+              </a:rPr>
+              <a:t>배치에서 검증된 방법론(exp44d2, 33.8dB)을 density/pruning 결정에 이식. 단, 12F 재튜닝 전이라 3장면 다 27dB 안정화 전 — CLAUDE.md 순서 제약과 맞물림.</a:t>
+            </a:r>
+          </a:p>
+        </p:txBody>
+      </p:sp>
+      <p:sp>
+        <p:nvSpPr>
+          <p:cNvPr id="10" name="Rounded Rectangle 9"/>
+          <p:cNvSpPr/>
+          <p:nvPr/>
+        </p:nvSpPr>
+        <p:spPr>
+          <a:xfrm>
+            <a:off x="548640" y="3337560"/>
+            <a:ext cx="1600200" cy="292608"/>
+          </a:xfrm>
+          <a:prstGeom prst="roundRect">
+            <a:avLst>
+              <a:gd name="adj" fmla="val 50000"/>
+            </a:avLst>
+          </a:prstGeom>
+          <a:solidFill>
+            <a:srgbClr val="1A1F2B"/>
+          </a:solidFill>
+          <a:ln w="12700">
+            <a:solidFill>
+              <a:srgbClr val="EF6A5C"/>
+            </a:solidFill>
+          </a:ln>
+          <a:effectLst/>
+        </p:spPr>
+        <p:style>
+          <a:lnRef idx="1">
+            <a:schemeClr val="accent1"/>
+          </a:lnRef>
+          <a:fillRef idx="3">
+            <a:schemeClr val="accent1"/>
+          </a:fillRef>
+          <a:effectRef idx="2">
+            <a:schemeClr val="accent1"/>
+          </a:effectRef>
+          <a:fontRef idx="minor">
+            <a:schemeClr val="lt1"/>
+          </a:fontRef>
+        </p:style>
+        <p:txBody>
+          <a:bodyPr rtlCol="0" anchor="ctr" lIns="45720" rIns="45720"/>
+          <a:lstStyle/>
+          <a:p>
+            <a:pPr algn="ctr"/>
+            <a:r>
+              <a:rPr sz="950" b="1">
+                <a:solidFill>
+                  <a:srgbClr val="EF6A5C"/>
+                </a:solidFill>
+                <a:latin typeface="Noto Sans CJK KR"/>
+              </a:rPr>
+              <a:t>③ 예산 robust화</a:t>
+            </a:r>
+          </a:p>
+        </p:txBody>
+      </p:sp>
+      <p:sp>
+        <p:nvSpPr>
+          <p:cNvPr id="11" name="TextBox 10"/>
+          <p:cNvSpPr txBox="1"/>
+          <p:nvPr/>
+        </p:nvSpPr>
+        <p:spPr>
+          <a:xfrm>
+            <a:off x="2331720" y="3310128"/>
+            <a:ext cx="9311335" cy="457200"/>
+          </a:xfrm>
+          <a:prstGeom prst="rect">
+            <a:avLst/>
+          </a:prstGeom>
+          <a:noFill/>
+        </p:spPr>
+        <p:txBody>
+          <a:bodyPr wrap="square" anchor="ctr">
+            <a:spAutoFit/>
+          </a:bodyPr>
+          <a:lstStyle/>
+          <a:p>
+            <a:pPr algn="l">
+              <a:lnSpc>
+                <a:spcPct val="100000"/>
+              </a:lnSpc>
+            </a:pPr>
+            <a:r>
+              <a:rPr sz="1250" b="0">
+                <a:solidFill>
+                  <a:srgbClr val="E8ECF4"/>
+                </a:solidFill>
+                <a:latin typeface="Noto Sans CJK KR"/>
+              </a:rPr>
+              <a:t>tracking에 시간 캡을 걸 것인가, polish에 최소 하한을 보장할 것인가 — 1253+305+12F 세 장면 교차검증 필수(A2가 두 장면만 보고 실패한 패턴 반복 금지).</a:t>
+            </a:r>
+          </a:p>
+        </p:txBody>
+      </p:sp>
+      <p:sp>
+        <p:nvSpPr>
+          <p:cNvPr id="12" name="Rounded Rectangle 11"/>
+          <p:cNvSpPr/>
+          <p:nvPr/>
+        </p:nvSpPr>
+        <p:spPr>
+          <a:xfrm>
+            <a:off x="548640" y="4297680"/>
+            <a:ext cx="1600200" cy="292608"/>
+          </a:xfrm>
+          <a:prstGeom prst="roundRect">
+            <a:avLst>
+              <a:gd name="adj" fmla="val 50000"/>
+            </a:avLst>
+          </a:prstGeom>
+          <a:solidFill>
+            <a:srgbClr val="1A1F2B"/>
+          </a:solidFill>
+          <a:ln w="12700">
+            <a:solidFill>
+              <a:srgbClr val="B48CF0"/>
+            </a:solidFill>
+          </a:ln>
+          <a:effectLst/>
+        </p:spPr>
+        <p:style>
+          <a:lnRef idx="1">
+            <a:schemeClr val="accent1"/>
+          </a:lnRef>
+          <a:fillRef idx="3">
+            <a:schemeClr val="accent1"/>
+          </a:fillRef>
+          <a:effectRef idx="2">
+            <a:schemeClr val="accent1"/>
+          </a:effectRef>
+          <a:fontRef idx="minor">
+            <a:schemeClr val="lt1"/>
+          </a:fontRef>
+        </p:style>
+        <p:txBody>
+          <a:bodyPr rtlCol="0" anchor="ctr" lIns="45720" rIns="45720"/>
+          <a:lstStyle/>
+          <a:p>
+            <a:pPr algn="ctr"/>
+            <a:r>
+              <a:rPr sz="950" b="1">
+                <a:solidFill>
+                  <a:srgbClr val="B48CF0"/>
+                </a:solidFill>
+                <a:latin typeface="Noto Sans CJK KR"/>
+              </a:rPr>
+              <a:t>④ FREEZE 스케줄</a:t>
+            </a:r>
+          </a:p>
+        </p:txBody>
+      </p:sp>
+      <p:sp>
+        <p:nvSpPr>
+          <p:cNvPr id="13" name="TextBox 12"/>
+          <p:cNvSpPr txBox="1"/>
+          <p:nvPr/>
+        </p:nvSpPr>
+        <p:spPr>
+          <a:xfrm>
+            <a:off x="2331720" y="4270248"/>
+            <a:ext cx="9311335" cy="457200"/>
+          </a:xfrm>
+          <a:prstGeom prst="rect">
+            <a:avLst/>
+          </a:prstGeom>
+          <a:noFill/>
+        </p:spPr>
+        <p:txBody>
+          <a:bodyPr wrap="square" anchor="ctr">
+            <a:spAutoFit/>
+          </a:bodyPr>
+          <a:lstStyle/>
+          <a:p>
+            <a:pPr algn="l">
+              <a:lnSpc>
+                <a:spcPct val="100000"/>
+              </a:lnSpc>
+            </a:pPr>
+            <a:r>
+              <a:rPr sz="1250" b="0">
+                <a:solidFill>
+                  <a:srgbClr val="E8ECF4"/>
+                </a:solidFill>
+                <a:latin typeface="Noto Sans CJK KR"/>
+              </a:rPr>
+              <a:t>①과 본질적으로 같은 문제. iteration/frame count가 아닌 기준(coverage 신호 등)으로 대체 — 지금 죽어있는 `transmittance` 계산이 후보 재료.</a:t>
+            </a:r>
+          </a:p>
+        </p:txBody>
+      </p:sp>
+      <p:sp>
+        <p:nvSpPr>
+          <p:cNvPr id="14" name="TextBox 13"/>
+          <p:cNvSpPr txBox="1"/>
+          <p:nvPr/>
+        </p:nvSpPr>
+        <p:spPr>
+          <a:xfrm>
+            <a:off x="548640" y="5394960"/>
+            <a:ext cx="11094415" cy="548640"/>
+          </a:xfrm>
+          <a:prstGeom prst="rect">
+            <a:avLst/>
+          </a:prstGeom>
+          <a:noFill/>
+        </p:spPr>
+        <p:txBody>
+          <a:bodyPr wrap="square" anchor="t">
+            <a:spAutoFit/>
+          </a:bodyPr>
+          <a:lstStyle/>
+          <a:p>
+            <a:pPr algn="l">
+              <a:lnSpc>
+                <a:spcPct val="100000"/>
+              </a:lnSpc>
+            </a:pPr>
+            <a:r>
+              <a:rPr sz="1200" b="1">
+                <a:solidFill>
+                  <a:srgbClr val="E8ECF4"/>
+                </a:solidFill>
+                <a:latin typeface="Noto Sans CJK KR"/>
+              </a:rPr>
+              <a:t>①④(freeze 기준)와 ③(예산 배분)은 사실 하나의 문제 — "제한된 실시간 예산을 구조 생성과 정제에 어떻게 나누는가". ②(carve)는 그 정제 단계의 품질을 결정한다.</a:t>
+            </a:r>
+          </a:p>
+        </p:txBody>
+      </p:sp>
+    </p:spTree>
+  </p:cSld>
+  <p:clrMapOvr>
+    <a:masterClrMapping/>
+  </p:clrMapOvr>
+</p:sld>
+</file>
+
+<file path=ppt/slides/slide18.xml><?xml version="1.0" encoding="utf-8"?>
+<p:sld xmlns:a="http://schemas.openxmlformats.org/drawingml/2006/main" xmlns:p="http://schemas.openxmlformats.org/presentationml/2006/main" xmlns:r="http://schemas.openxmlformats.org/officeDocument/2006/relationships">
+  <p:cSld>
+    <p:spTree>
+      <p:nvGrpSpPr>
+        <p:cNvPr id="1" name=""/>
+        <p:cNvGrpSpPr/>
+        <p:nvPr/>
+      </p:nvGrpSpPr>
+      <p:grpSpPr/>
+      <p:sp>
+        <p:nvSpPr>
+          <p:cNvPr id="2" name="Rectangle 1"/>
+          <p:cNvSpPr/>
+          <p:nvPr/>
+        </p:nvSpPr>
+        <p:spPr>
+          <a:xfrm>
+            <a:off x="0" y="0"/>
+            <a:ext cx="12191695" cy="6858000"/>
+          </a:xfrm>
+          <a:prstGeom prst="rect">
+            <a:avLst/>
+          </a:prstGeom>
+          <a:solidFill>
+            <a:srgbClr val="12151C"/>
+          </a:solidFill>
+          <a:ln>
+            <a:noFill/>
+          </a:ln>
+          <a:effectLst/>
+        </p:spPr>
+        <p:style>
+          <a:lnRef idx="1">
+            <a:schemeClr val="accent1"/>
+          </a:lnRef>
+          <a:fillRef idx="3">
+            <a:schemeClr val="accent1"/>
+          </a:fillRef>
+          <a:effectRef idx="2">
+            <a:schemeClr val="accent1"/>
+          </a:effectRef>
+          <a:fontRef idx="minor">
+            <a:schemeClr val="lt1"/>
+          </a:fontRef>
+        </p:style>
+        <p:txBody>
+          <a:bodyPr rtlCol="0" anchor="ctr"/>
+          <a:lstStyle/>
+          <a:p>
+            <a:pPr algn="ctr"/>
+          </a:p>
+        </p:txBody>
+      </p:sp>
+      <p:sp>
+        <p:nvSpPr>
+          <p:cNvPr id="3" name="TextBox 2"/>
+          <p:cNvSpPr txBox="1"/>
+          <p:nvPr/>
+        </p:nvSpPr>
+        <p:spPr>
+          <a:xfrm>
+            <a:off x="548640" y="320040"/>
+            <a:ext cx="11094415" cy="292608"/>
+          </a:xfrm>
+          <a:prstGeom prst="rect">
+            <a:avLst/>
+          </a:prstGeom>
+          <a:noFill/>
+        </p:spPr>
+        <p:txBody>
+          <a:bodyPr wrap="square" anchor="t">
+            <a:spAutoFit/>
+          </a:bodyPr>
+          <a:lstStyle/>
+          <a:p>
+            <a:pPr algn="l">
+              <a:lnSpc>
+                <a:spcPct val="100000"/>
+              </a:lnSpc>
+            </a:pPr>
+            <a:r>
+              <a:rPr sz="1200" b="1">
+                <a:solidFill>
+                  <a:srgbClr val="FFB454"/>
+                </a:solidFill>
+                <a:latin typeface="Noto Sans CJK KR"/>
+              </a:rPr>
+              <a:t>ROADMAP · PROGRESS</a:t>
+            </a:r>
+          </a:p>
+        </p:txBody>
+      </p:sp>
+      <p:sp>
+        <p:nvSpPr>
+          <p:cNvPr id="4" name="TextBox 3"/>
+          <p:cNvSpPr txBox="1"/>
+          <p:nvPr/>
+        </p:nvSpPr>
+        <p:spPr>
+          <a:xfrm>
+            <a:off x="548640" y="566928"/>
+            <a:ext cx="11094415" cy="548640"/>
+          </a:xfrm>
+          <a:prstGeom prst="rect">
+            <a:avLst/>
+          </a:prstGeom>
+          <a:noFill/>
+        </p:spPr>
+        <p:txBody>
+          <a:bodyPr wrap="square" anchor="t">
+            <a:spAutoFit/>
+          </a:bodyPr>
+          <a:lstStyle/>
+          <a:p>
+            <a:pPr algn="l">
+              <a:lnSpc>
+                <a:spcPct val="100000"/>
+              </a:lnSpc>
+            </a:pPr>
+            <a:r>
+              <a:rPr sz="2200" b="1">
+                <a:solidFill>
+                  <a:srgbClr val="E8ECF4"/>
+                </a:solidFill>
+                <a:latin typeface="Noto Sans CJK KR"/>
+              </a:rPr>
+              <a:t>계획했던 4단계 중 어디까지 왔나</a:t>
+            </a:r>
+          </a:p>
+        </p:txBody>
+      </p:sp>
+      <p:sp>
+        <p:nvSpPr>
+          <p:cNvPr id="5" name="Rectangle 4"/>
+          <p:cNvSpPr/>
+          <p:nvPr/>
+        </p:nvSpPr>
+        <p:spPr>
+          <a:xfrm>
+            <a:off x="548640" y="1078992"/>
+            <a:ext cx="11094415" cy="25400"/>
+          </a:xfrm>
+          <a:prstGeom prst="rect">
+            <a:avLst/>
+          </a:prstGeom>
+          <a:solidFill>
+            <a:srgbClr val="2A3242"/>
+          </a:solidFill>
+          <a:ln>
+            <a:noFill/>
+          </a:ln>
+          <a:effectLst/>
+        </p:spPr>
+        <p:style>
+          <a:lnRef idx="1">
+            <a:schemeClr val="accent1"/>
+          </a:lnRef>
+          <a:fillRef idx="3">
+            <a:schemeClr val="accent1"/>
+          </a:fillRef>
+          <a:effectRef idx="2">
+            <a:schemeClr val="accent1"/>
+          </a:effectRef>
+          <a:fontRef idx="minor">
+            <a:schemeClr val="lt1"/>
+          </a:fontRef>
+        </p:style>
+        <p:txBody>
+          <a:bodyPr rtlCol="0" anchor="ctr"/>
+          <a:lstStyle/>
+          <a:p>
+            <a:pPr algn="ctr"/>
+          </a:p>
+        </p:txBody>
+      </p:sp>
+      <p:pic>
+        <p:nvPicPr>
+          <p:cNvPr id="6" name="Picture 5" descr="fig_next_steps.png"/>
+          <p:cNvPicPr>
+            <a:picLocks noChangeAspect="1"/>
+          </p:cNvPicPr>
+          <p:nvPr/>
+        </p:nvPicPr>
+        <p:blipFill>
+          <a:blip r:embed="rId2"/>
+          <a:stretch>
+            <a:fillRect/>
+          </a:stretch>
+        </p:blipFill>
+        <p:spPr>
+          <a:xfrm>
+            <a:off x="3004490" y="1371600"/>
+            <a:ext cx="6182713" cy="2651760"/>
+          </a:xfrm>
+          <a:prstGeom prst="rect">
+            <a:avLst/>
+          </a:prstGeom>
+        </p:spPr>
+      </p:pic>
+      <p:sp>
+        <p:nvSpPr>
+          <p:cNvPr id="7" name="Rounded Rectangle 6"/>
+          <p:cNvSpPr/>
+          <p:nvPr/>
+        </p:nvSpPr>
+        <p:spPr>
+          <a:xfrm>
+            <a:off x="548640" y="4297680"/>
+            <a:ext cx="1600200" cy="292608"/>
+          </a:xfrm>
+          <a:prstGeom prst="roundRect">
+            <a:avLst>
+              <a:gd name="adj" fmla="val 50000"/>
+            </a:avLst>
+          </a:prstGeom>
+          <a:solidFill>
+            <a:srgbClr val="1A1F2B"/>
+          </a:solidFill>
+          <a:ln w="12700">
+            <a:solidFill>
+              <a:srgbClr val="5FD68A"/>
+            </a:solidFill>
+          </a:ln>
+          <a:effectLst/>
+        </p:spPr>
+        <p:style>
+          <a:lnRef idx="1">
+            <a:schemeClr val="accent1"/>
+          </a:lnRef>
+          <a:fillRef idx="3">
+            <a:schemeClr val="accent1"/>
+          </a:fillRef>
+          <a:effectRef idx="2">
+            <a:schemeClr val="accent1"/>
+          </a:effectRef>
+          <a:fontRef idx="minor">
+            <a:schemeClr val="lt1"/>
+          </a:fontRef>
+        </p:style>
+        <p:txBody>
+          <a:bodyPr rtlCol="0" anchor="ctr" lIns="45720" rIns="45720"/>
+          <a:lstStyle/>
+          <a:p>
+            <a:pPr algn="ctr"/>
+            <a:r>
+              <a:rPr sz="950" b="1">
+                <a:solidFill>
+                  <a:srgbClr val="5FD68A"/>
+                </a:solidFill>
+                <a:latin typeface="Noto Sans CJK KR"/>
+              </a:rPr>
+              <a:t>STEP 1 완료</a:t>
+            </a:r>
+          </a:p>
+        </p:txBody>
+      </p:sp>
+      <p:sp>
+        <p:nvSpPr>
+          <p:cNvPr id="8" name="TextBox 7"/>
+          <p:cNvSpPr txBox="1"/>
+          <p:nvPr/>
+        </p:nvSpPr>
+        <p:spPr>
+          <a:xfrm>
+            <a:off x="2331720" y="4270248"/>
+            <a:ext cx="9311335" cy="457200"/>
+          </a:xfrm>
+          <a:prstGeom prst="rect">
+            <a:avLst/>
+          </a:prstGeom>
+          <a:noFill/>
+        </p:spPr>
+        <p:txBody>
+          <a:bodyPr wrap="square" anchor="ctr">
+            <a:spAutoFit/>
+          </a:bodyPr>
+          <a:lstStyle/>
+          <a:p>
+            <a:pPr algn="l">
+              <a:lnSpc>
+                <a:spcPct val="100000"/>
+              </a:lnSpc>
+            </a:pPr>
+            <a:r>
+              <a:rPr sz="1250" b="0">
+                <a:solidFill>
+                  <a:srgbClr val="E8ECF4"/>
+                </a:solidFill>
+                <a:latin typeface="Noto Sans CJK KR"/>
+              </a:rPr>
+              <a:t>A2 전/후 × 12F/305 4개 조합을 `VIGS_TIMING_LOG` 켜서 재실행·재분석 완료 — frontend 73.4%/64.0%, polish 5,683/822/9,866회 등 실측 확보.</a:t>
+            </a:r>
+          </a:p>
+        </p:txBody>
+      </p:sp>
+      <p:sp>
+        <p:nvSpPr>
+          <p:cNvPr id="9" name="Rounded Rectangle 8"/>
+          <p:cNvSpPr/>
+          <p:nvPr/>
+        </p:nvSpPr>
+        <p:spPr>
+          <a:xfrm>
+            <a:off x="548640" y="4828032"/>
+            <a:ext cx="1600200" cy="292608"/>
+          </a:xfrm>
+          <a:prstGeom prst="roundRect">
+            <a:avLst>
+              <a:gd name="adj" fmla="val 50000"/>
+            </a:avLst>
+          </a:prstGeom>
+          <a:solidFill>
+            <a:srgbClr val="1A1F2B"/>
+          </a:solidFill>
+          <a:ln w="12700">
+            <a:solidFill>
+              <a:srgbClr val="5FD68A"/>
+            </a:solidFill>
+          </a:ln>
+          <a:effectLst/>
+        </p:spPr>
+        <p:style>
+          <a:lnRef idx="1">
+            <a:schemeClr val="accent1"/>
+          </a:lnRef>
+          <a:fillRef idx="3">
+            <a:schemeClr val="accent1"/>
+          </a:fillRef>
+          <a:effectRef idx="2">
+            <a:schemeClr val="accent1"/>
+          </a:effectRef>
+          <a:fontRef idx="minor">
+            <a:schemeClr val="lt1"/>
+          </a:fontRef>
+        </p:style>
+        <p:txBody>
+          <a:bodyPr rtlCol="0" anchor="ctr" lIns="45720" rIns="45720"/>
+          <a:lstStyle/>
+          <a:p>
+            <a:pPr algn="ctr"/>
+            <a:r>
+              <a:rPr sz="950" b="1">
+                <a:solidFill>
+                  <a:srgbClr val="5FD68A"/>
+                </a:solidFill>
+                <a:latin typeface="Noto Sans CJK KR"/>
+              </a:rPr>
+              <a:t>STEP 2 완료</a:t>
+            </a:r>
+          </a:p>
+        </p:txBody>
+      </p:sp>
+      <p:sp>
+        <p:nvSpPr>
+          <p:cNvPr id="10" name="TextBox 9"/>
+          <p:cNvSpPr txBox="1"/>
+          <p:nvPr/>
+        </p:nvSpPr>
+        <p:spPr>
+          <a:xfrm>
+            <a:off x="2331720" y="4800600"/>
+            <a:ext cx="9311335" cy="457200"/>
+          </a:xfrm>
+          <a:prstGeom prst="rect">
+            <a:avLst/>
+          </a:prstGeom>
+          <a:noFill/>
+        </p:spPr>
+        <p:txBody>
+          <a:bodyPr wrap="square" anchor="ctr">
+            <a:spAutoFit/>
+          </a:bodyPr>
+          <a:lstStyle/>
+          <a:p>
+            <a:pPr algn="l">
+              <a:lnSpc>
+                <a:spcPct val="100000"/>
+              </a:lnSpc>
+            </a:pPr>
+            <a:r>
+              <a:rPr sz="1250" b="0">
+                <a:solidFill>
+                  <a:srgbClr val="E8ECF4"/>
+                </a:solidFill>
+                <a:latin typeface="Noto Sans CJK KR"/>
+              </a:rPr>
+              <a:t>`background_polish_step`에 `_Sect` 계측 추가 완료 — call당 3.9~6.4ms, n_gauss 의존성 약함(주 원인 아님) 확정.</a:t>
+            </a:r>
+          </a:p>
+        </p:txBody>
+      </p:sp>
+      <p:sp>
+        <p:nvSpPr>
+          <p:cNvPr id="11" name="Rounded Rectangle 10"/>
+          <p:cNvSpPr/>
+          <p:nvPr/>
+        </p:nvSpPr>
+        <p:spPr>
+          <a:xfrm>
+            <a:off x="548640" y="5358384"/>
+            <a:ext cx="1600200" cy="292608"/>
+          </a:xfrm>
+          <a:prstGeom prst="roundRect">
+            <a:avLst>
+              <a:gd name="adj" fmla="val 50000"/>
+            </a:avLst>
+          </a:prstGeom>
+          <a:solidFill>
+            <a:srgbClr val="1A1F2B"/>
+          </a:solidFill>
+          <a:ln w="12700">
+            <a:solidFill>
+              <a:srgbClr val="8B95AB"/>
+            </a:solidFill>
+          </a:ln>
+          <a:effectLst/>
+        </p:spPr>
+        <p:style>
+          <a:lnRef idx="1">
+            <a:schemeClr val="accent1"/>
+          </a:lnRef>
+          <a:fillRef idx="3">
+            <a:schemeClr val="accent1"/>
+          </a:fillRef>
+          <a:effectRef idx="2">
+            <a:schemeClr val="accent1"/>
+          </a:effectRef>
+          <a:fontRef idx="minor">
+            <a:schemeClr val="lt1"/>
+          </a:fontRef>
+        </p:style>
+        <p:txBody>
+          <a:bodyPr rtlCol="0" anchor="ctr" lIns="45720" rIns="45720"/>
+          <a:lstStyle/>
+          <a:p>
+            <a:pPr algn="ctr"/>
+            <a:r>
+              <a:rPr sz="950" b="1">
+                <a:solidFill>
+                  <a:srgbClr val="8B95AB"/>
+                </a:solidFill>
+                <a:latin typeface="Noto Sans CJK KR"/>
+              </a:rPr>
+              <a:t>STEP 3 보류</a:t>
+            </a:r>
+          </a:p>
+        </p:txBody>
+      </p:sp>
+      <p:sp>
+        <p:nvSpPr>
+          <p:cNvPr id="12" name="TextBox 11"/>
+          <p:cNvSpPr txBox="1"/>
+          <p:nvPr/>
+        </p:nvSpPr>
+        <p:spPr>
+          <a:xfrm>
+            <a:off x="2331720" y="5330952"/>
+            <a:ext cx="9311335" cy="457200"/>
+          </a:xfrm>
+          <a:prstGeom prst="rect">
+            <a:avLst/>
+          </a:prstGeom>
+          <a:noFill/>
+        </p:spPr>
+        <p:txBody>
+          <a:bodyPr wrap="square" anchor="ctr">
+            <a:spAutoFit/>
+          </a:bodyPr>
+          <a:lstStyle/>
+          <a:p>
+            <a:pPr algn="l">
+              <a:lnSpc>
+                <a:spcPct val="100000"/>
+              </a:lnSpc>
+            </a:pPr>
+            <a:r>
+              <a:rPr sz="1250" b="0">
+                <a:solidFill>
+                  <a:srgbClr val="E8ECF4"/>
+                </a:solidFill>
+                <a:latin typeface="Noto Sans CJK KR"/>
+              </a:rPr>
+              <a:t>시간축 병합 타임라인 재구성 — 이번엔 phase별 총합/스케일링으로 핵심 질문에 이미 답이 나와서 우선순위 낮춤. `get_lock()` 경합의 직접 증거는 아직 없음.</a:t>
+            </a:r>
+          </a:p>
+        </p:txBody>
+      </p:sp>
+      <p:sp>
+        <p:nvSpPr>
+          <p:cNvPr id="13" name="Rounded Rectangle 12"/>
+          <p:cNvSpPr/>
+          <p:nvPr/>
+        </p:nvSpPr>
+        <p:spPr>
+          <a:xfrm>
+            <a:off x="548640" y="5888736"/>
+            <a:ext cx="1600200" cy="292608"/>
+          </a:xfrm>
+          <a:prstGeom prst="roundRect">
+            <a:avLst>
+              <a:gd name="adj" fmla="val 50000"/>
+            </a:avLst>
+          </a:prstGeom>
+          <a:solidFill>
+            <a:srgbClr val="1A1F2B"/>
+          </a:solidFill>
+          <a:ln w="12700">
+            <a:solidFill>
+              <a:srgbClr val="5FD68A"/>
+            </a:solidFill>
+          </a:ln>
+          <a:effectLst/>
+        </p:spPr>
+        <p:style>
+          <a:lnRef idx="1">
+            <a:schemeClr val="accent1"/>
+          </a:lnRef>
+          <a:fillRef idx="3">
+            <a:schemeClr val="accent1"/>
+          </a:fillRef>
+          <a:effectRef idx="2">
+            <a:schemeClr val="accent1"/>
+          </a:effectRef>
+          <a:fontRef idx="minor">
+            <a:schemeClr val="lt1"/>
+          </a:fontRef>
+        </p:style>
+        <p:txBody>
+          <a:bodyPr rtlCol="0" anchor="ctr" lIns="45720" rIns="45720"/>
+          <a:lstStyle/>
+          <a:p>
+            <a:pPr algn="ctr"/>
+            <a:r>
+              <a:rPr sz="950" b="1">
+                <a:solidFill>
+                  <a:srgbClr val="5FD68A"/>
+                </a:solidFill>
+                <a:latin typeface="Noto Sans CJK KR"/>
+              </a:rPr>
+              <a:t>STEP 4 완료</a:t>
+            </a:r>
+          </a:p>
+        </p:txBody>
+      </p:sp>
+      <p:sp>
+        <p:nvSpPr>
+          <p:cNvPr id="14" name="TextBox 13"/>
+          <p:cNvSpPr txBox="1"/>
+          <p:nvPr/>
+        </p:nvSpPr>
+        <p:spPr>
+          <a:xfrm>
+            <a:off x="2331720" y="5861304"/>
+            <a:ext cx="9311335" cy="457200"/>
+          </a:xfrm>
+          <a:prstGeom prst="rect">
+            <a:avLst/>
+          </a:prstGeom>
+          <a:noFill/>
+        </p:spPr>
+        <p:txBody>
+          <a:bodyPr wrap="square" anchor="ctr">
+            <a:spAutoFit/>
+          </a:bodyPr>
+          <a:lstStyle/>
+          <a:p>
+            <a:pPr algn="l">
+              <a:lnSpc>
+                <a:spcPct val="100000"/>
+              </a:lnSpc>
+            </a:pPr>
+            <a:r>
+              <a:rPr sz="1250" b="0">
+                <a:solidFill>
+                  <a:srgbClr val="E8ECF4"/>
+                </a:solidFill>
+                <a:latin typeface="Noto Sans CJK KR"/>
+              </a:rPr>
+              <a:t>파라미터 스윕 — iters1 1↔2 한 쌍(×2.17) + `replay_time_scale` 1.5/2.0/3.0 3점 스윕(23.84/28.10/25.97dB, 역-U자형) 확보. gap 기반 양자화 메커니즘도 규명 완료. 3.0 역행의 근본원인(과적합 가설)만 미검증으로 남음.</a:t>
+            </a:r>
+          </a:p>
+        </p:txBody>
+      </p:sp>
+    </p:spTree>
+  </p:cSld>
+  <p:clrMapOvr>
+    <a:masterClrMapping/>
+  </p:clrMapOvr>
+</p:sld>
+</file>
+
+<file path=ppt/slides/slide19.xml><?xml version="1.0" encoding="utf-8"?>
+<p:sld xmlns:a="http://schemas.openxmlformats.org/drawingml/2006/main" xmlns:p="http://schemas.openxmlformats.org/presentationml/2006/main" xmlns:r="http://schemas.openxmlformats.org/officeDocument/2006/relationships">
+  <p:cSld>
+    <p:spTree>
+      <p:nvGrpSpPr>
+        <p:cNvPr id="1" name=""/>
+        <p:cNvGrpSpPr/>
+        <p:nvPr/>
+      </p:nvGrpSpPr>
+      <p:grpSpPr/>
+      <p:sp>
+        <p:nvSpPr>
+          <p:cNvPr id="2" name="Rectangle 1"/>
+          <p:cNvSpPr/>
+          <p:nvPr/>
+        </p:nvSpPr>
+        <p:spPr>
+          <a:xfrm>
+            <a:off x="0" y="0"/>
+            <a:ext cx="12191695" cy="6858000"/>
+          </a:xfrm>
+          <a:prstGeom prst="rect">
+            <a:avLst/>
+          </a:prstGeom>
+          <a:solidFill>
+            <a:srgbClr val="12151C"/>
+          </a:solidFill>
+          <a:ln>
+            <a:noFill/>
+          </a:ln>
+          <a:effectLst/>
+        </p:spPr>
+        <p:style>
+          <a:lnRef idx="1">
+            <a:schemeClr val="accent1"/>
+          </a:lnRef>
+          <a:fillRef idx="3">
+            <a:schemeClr val="accent1"/>
+          </a:fillRef>
+          <a:effectRef idx="2">
+            <a:schemeClr val="accent1"/>
+          </a:effectRef>
+          <a:fontRef idx="minor">
+            <a:schemeClr val="lt1"/>
+          </a:fontRef>
+        </p:style>
+        <p:txBody>
+          <a:bodyPr rtlCol="0" anchor="ctr"/>
+          <a:lstStyle/>
+          <a:p>
+            <a:pPr algn="ctr"/>
+          </a:p>
+        </p:txBody>
+      </p:sp>
+      <p:sp>
+        <p:nvSpPr>
+          <p:cNvPr id="3" name="TextBox 2"/>
+          <p:cNvSpPr txBox="1"/>
+          <p:nvPr/>
+        </p:nvSpPr>
+        <p:spPr>
+          <a:xfrm>
+            <a:off x="548640" y="320040"/>
+            <a:ext cx="11094415" cy="292608"/>
+          </a:xfrm>
+          <a:prstGeom prst="rect">
+            <a:avLst/>
+          </a:prstGeom>
+          <a:noFill/>
+        </p:spPr>
+        <p:txBody>
+          <a:bodyPr wrap="square" anchor="t">
+            <a:spAutoFit/>
+          </a:bodyPr>
+          <a:lstStyle/>
+          <a:p>
+            <a:pPr algn="l">
+              <a:lnSpc>
+                <a:spcPct val="100000"/>
+              </a:lnSpc>
+            </a:pPr>
+            <a:r>
+              <a:rPr sz="1200" b="1">
+                <a:solidFill>
+                  <a:srgbClr val="FFB454"/>
+                </a:solidFill>
+                <a:latin typeface="Noto Sans CJK KR"/>
+              </a:rPr>
               <a:t>CONCLUSIONS</a:t>
             </a:r>
           </a:p>
@@ -6309,7 +7469,7 @@
                 </a:solidFill>
                 <a:latin typeface="Noto Sans CJK KR"/>
               </a:rPr>
-              <a:t>두 스레드가 하나의 GPU를 나눠 쓰는 구조</a:t>
+              <a:t>세 스레드가 하나의 GPU를 나눠 쓰는 구조</a:t>
             </a:r>
           </a:p>
         </p:txBody>
@@ -6374,8 +7534,8 @@
         </p:blipFill>
         <p:spPr>
           <a:xfrm>
-            <a:off x="2448421" y="1280160"/>
-            <a:ext cx="7294852" cy="4160520"/>
+            <a:off x="2496079" y="1234440"/>
+            <a:ext cx="7199536" cy="4709160"/>
           </a:xfrm>
           <a:prstGeom prst="rect">
             <a:avLst/>
@@ -6390,8 +7550,8 @@
         </p:nvSpPr>
         <p:spPr>
           <a:xfrm>
-            <a:off x="548640" y="5623560"/>
-            <a:ext cx="11094415" cy="914400"/>
+            <a:off x="548640" y="6053328"/>
+            <a:ext cx="11094415" cy="685800"/>
           </a:xfrm>
           <a:prstGeom prst="rect">
             <a:avLst/>
@@ -6406,17 +7566,17 @@
           <a:p>
             <a:pPr algn="l">
               <a:lnSpc>
-                <a:spcPct val="125000"/>
+                <a:spcPct val="120000"/>
               </a:lnSpc>
             </a:pPr>
             <a:r>
-              <a:rPr sz="1250" b="0">
+              <a:rPr sz="1150" b="0">
                 <a:solidFill>
                   <a:srgbClr val="8B95AB"/>
                 </a:solidFill>
                 <a:latin typeface="Noto Sans CJK KR"/>
               </a:rPr>
-              <a:t>tracking 스레드(motion_filter→frontend→PGBA)는 동기·고정 반복(iters1)으로 돈다 — 시간 예산 캡이 코드 어디에도 없다. gs_worker 스레드(map()/background_polish)는 큐가 빌 때만 polish를 시도하는 idle-gated 구조라, tracking이 바빠질수록 polish 몫이 일방적으로 줄어든다. 이 비대칭이 오늘 발견한 회귀의 근본 구조다.</a:t>
+              <a:t>tracking 스레드는 동기·고정 반복(iters1)으로 돈다 — 시간 예산 캡이 코드 어디에도 없다. PGBA는 매 프레임 값싼 큐 확인만 하고, 실제 pose-graph BA는 별도 loop-closure 검출 스레드가 후보를 큐잉했을 때만 실행된다(상시 실행 아님). get_lock() 직렬화는 PGBA↔background_polish_step에만 적용되며 map()은 이 락을 쓰지 않는다.</a:t>
             </a:r>
           </a:p>
         </p:txBody>
@@ -6517,7 +7677,7 @@
                 </a:solidFill>
                 <a:latin typeface="Noto Sans CJK KR"/>
               </a:rPr>
-              <a:t>EVIDENCE #1</a:t>
+              <a:t>MECHANISM · MICRO</a:t>
             </a:r>
           </a:p>
         </p:txBody>
@@ -6556,7 +7716,7 @@
                 </a:solidFill>
                 <a:latin typeface="Noto Sans CJK KR"/>
               </a:rPr>
-              <a:t>같은 파라미터, 정반대 결과 — 실측</a:t>
+              <a:t>프레임 1개 주기 안에서 무슨 일이 일어나는가</a:t>
             </a:r>
           </a:p>
         </p:txBody>
@@ -6607,7 +7767,7 @@
       </p:sp>
       <p:pic>
         <p:nvPicPr>
-          <p:cNvPr id="6" name="Picture 5" descr="fig_a2_scene_flip.png"/>
+          <p:cNvPr id="6" name="Picture 5" descr="fig_frame_cycle.png"/>
           <p:cNvPicPr>
             <a:picLocks noChangeAspect="1"/>
           </p:cNvPicPr>
@@ -6621,8 +7781,8 @@
         </p:blipFill>
         <p:spPr>
           <a:xfrm>
-            <a:off x="2997283" y="1280160"/>
-            <a:ext cx="6197127" cy="3794760"/>
+            <a:off x="548640" y="1330358"/>
+            <a:ext cx="11094415" cy="5111683"/>
           </a:xfrm>
           <a:prstGeom prst="rect">
             <a:avLst/>
@@ -6631,207 +7791,39 @@
       </p:pic>
       <p:sp>
         <p:nvSpPr>
-          <p:cNvPr id="7" name="Rounded Rectangle 6"/>
-          <p:cNvSpPr/>
-          <p:nvPr/>
-        </p:nvSpPr>
-        <p:spPr>
-          <a:xfrm>
-            <a:off x="548640" y="5257800"/>
-            <a:ext cx="3566160" cy="1005840"/>
-          </a:xfrm>
-          <a:prstGeom prst="roundRect">
-            <a:avLst>
-              <a:gd name="adj" fmla="val 8000"/>
-            </a:avLst>
-          </a:prstGeom>
-          <a:solidFill>
-            <a:srgbClr val="1A1F2B"/>
-          </a:solidFill>
-          <a:ln w="15875">
-            <a:solidFill>
-              <a:srgbClr val="5FD68A"/>
-            </a:solidFill>
-          </a:ln>
-          <a:effectLst/>
-        </p:spPr>
-        <p:style>
-          <a:lnRef idx="1">
-            <a:schemeClr val="accent1"/>
-          </a:lnRef>
-          <a:fillRef idx="3">
-            <a:schemeClr val="accent1"/>
-          </a:fillRef>
-          <a:effectRef idx="2">
-            <a:schemeClr val="accent1"/>
-          </a:effectRef>
-          <a:fontRef idx="minor">
-            <a:schemeClr val="lt1"/>
-          </a:fontRef>
-        </p:style>
-        <p:txBody>
-          <a:bodyPr rtlCol="0" anchor="ctr" wrap="square" lIns="146304" rIns="146304"/>
-          <a:lstStyle/>
-          <a:p>
-            <a:pPr algn="ctr"/>
-            <a:r>
-              <a:rPr sz="2200" b="1">
-                <a:solidFill>
-                  <a:srgbClr val="5FD68A"/>
-                </a:solidFill>
-                <a:latin typeface="Noto Sans CJK KR"/>
-              </a:rPr>
-              <a:t>+7.00 dB</a:t>
-            </a:r>
-          </a:p>
-          <a:p>
-            <a:pPr algn="ctr"/>
-            <a:r>
-              <a:rPr sz="1050">
+          <p:cNvPr id="7" name="TextBox 6"/>
+          <p:cNvSpPr txBox="1"/>
+          <p:nvPr/>
+        </p:nvSpPr>
+        <p:spPr>
+          <a:xfrm>
+            <a:off x="548640" y="6537960"/>
+            <a:ext cx="11094415" cy="274320"/>
+          </a:xfrm>
+          <a:prstGeom prst="rect">
+            <a:avLst/>
+          </a:prstGeom>
+          <a:noFill/>
+        </p:spPr>
+        <p:txBody>
+          <a:bodyPr wrap="square" anchor="t">
+            <a:spAutoFit/>
+          </a:bodyPr>
+          <a:lstStyle/>
+          <a:p>
+            <a:pPr algn="l">
+              <a:lnSpc>
+                <a:spcPct val="120000"/>
+              </a:lnSpc>
+            </a:pPr>
+            <a:r>
+              <a:rPr sz="1150" b="0">
                 <a:solidFill>
                   <a:srgbClr val="8B95AB"/>
                 </a:solidFill>
                 <a:latin typeface="Noto Sans CJK KR"/>
               </a:rPr>
-              <a:t>305 (원래 부족)</a:t>
-            </a:r>
-          </a:p>
-        </p:txBody>
-      </p:sp>
-      <p:sp>
-        <p:nvSpPr>
-          <p:cNvPr id="8" name="Rounded Rectangle 7"/>
-          <p:cNvSpPr/>
-          <p:nvPr/>
-        </p:nvSpPr>
-        <p:spPr>
-          <a:xfrm>
-            <a:off x="4297679" y="5257800"/>
-            <a:ext cx="3566160" cy="1005840"/>
-          </a:xfrm>
-          <a:prstGeom prst="roundRect">
-            <a:avLst>
-              <a:gd name="adj" fmla="val 8000"/>
-            </a:avLst>
-          </a:prstGeom>
-          <a:solidFill>
-            <a:srgbClr val="1A1F2B"/>
-          </a:solidFill>
-          <a:ln w="15875">
-            <a:solidFill>
-              <a:srgbClr val="EF6A5C"/>
-            </a:solidFill>
-          </a:ln>
-          <a:effectLst/>
-        </p:spPr>
-        <p:style>
-          <a:lnRef idx="1">
-            <a:schemeClr val="accent1"/>
-          </a:lnRef>
-          <a:fillRef idx="3">
-            <a:schemeClr val="accent1"/>
-          </a:fillRef>
-          <a:effectRef idx="2">
-            <a:schemeClr val="accent1"/>
-          </a:effectRef>
-          <a:fontRef idx="minor">
-            <a:schemeClr val="lt1"/>
-          </a:fontRef>
-        </p:style>
-        <p:txBody>
-          <a:bodyPr rtlCol="0" anchor="ctr" wrap="square" lIns="146304" rIns="146304"/>
-          <a:lstStyle/>
-          <a:p>
-            <a:pPr algn="ctr"/>
-            <a:r>
-              <a:rPr sz="2200" b="1">
-                <a:solidFill>
-                  <a:srgbClr val="EF6A5C"/>
-                </a:solidFill>
-                <a:latin typeface="Noto Sans CJK KR"/>
-              </a:rPr>
-              <a:t>-4.84 dB</a:t>
-            </a:r>
-          </a:p>
-          <a:p>
-            <a:pPr algn="ctr"/>
-            <a:r>
-              <a:rPr sz="1050">
-                <a:solidFill>
-                  <a:srgbClr val="8B95AB"/>
-                </a:solidFill>
-                <a:latin typeface="Noto Sans CJK KR"/>
-              </a:rPr>
-              <a:t>12F (원래 충분)</a:t>
-            </a:r>
-          </a:p>
-        </p:txBody>
-      </p:sp>
-      <p:sp>
-        <p:nvSpPr>
-          <p:cNvPr id="9" name="Rounded Rectangle 8"/>
-          <p:cNvSpPr/>
-          <p:nvPr/>
-        </p:nvSpPr>
-        <p:spPr>
-          <a:xfrm>
-            <a:off x="8046719" y="5257800"/>
-            <a:ext cx="3657600" cy="1005840"/>
-          </a:xfrm>
-          <a:prstGeom prst="roundRect">
-            <a:avLst>
-              <a:gd name="adj" fmla="val 8000"/>
-            </a:avLst>
-          </a:prstGeom>
-          <a:solidFill>
-            <a:srgbClr val="1A1F2B"/>
-          </a:solidFill>
-          <a:ln w="15875">
-            <a:solidFill>
-              <a:srgbClr val="FFB454"/>
-            </a:solidFill>
-          </a:ln>
-          <a:effectLst/>
-        </p:spPr>
-        <p:style>
-          <a:lnRef idx="1">
-            <a:schemeClr val="accent1"/>
-          </a:lnRef>
-          <a:fillRef idx="3">
-            <a:schemeClr val="accent1"/>
-          </a:fillRef>
-          <a:effectRef idx="2">
-            <a:schemeClr val="accent1"/>
-          </a:effectRef>
-          <a:fontRef idx="minor">
-            <a:schemeClr val="lt1"/>
-          </a:fontRef>
-        </p:style>
-        <p:txBody>
-          <a:bodyPr rtlCol="0" anchor="ctr" wrap="square" lIns="146304" rIns="146304"/>
-          <a:lstStyle/>
-          <a:p>
-            <a:pPr algn="ctr"/>
-            <a:r>
-              <a:rPr sz="2200" b="1">
-                <a:solidFill>
-                  <a:srgbClr val="FFB454"/>
-                </a:solidFill>
-                <a:latin typeface="Noto Sans CJK KR"/>
-              </a:rPr>
-              <a:t>12F 미검증 방치</a:t>
-            </a:r>
-          </a:p>
-          <a:p>
-            <a:pPr algn="ctr"/>
-            <a:r>
-              <a:rPr sz="1050">
-                <a:solidFill>
-                  <a:srgbClr val="8B95AB"/>
-                </a:solidFill>
-                <a:latin typeface="Noto Sans CJK KR"/>
-              </a:rPr>
-              <a:t>검증 상태</a:t>
+              <a:t>track(t)는 프레임마다 정확히 1번 — busy(추적 계산)와 idle(다음 프레임 예정시각까지 대기) 구간을 오가며, idle 구간에만 background_polish_step이 낄 수 있다.</a:t>
             </a:r>
           </a:p>
         </p:txBody>
@@ -6932,7 +7924,7 @@
                 </a:solidFill>
                 <a:latin typeface="Noto Sans CJK KR"/>
               </a:rPr>
-              <a:t>EVIDENCE #2</a:t>
+              <a:t>MECHANISM · MACRO</a:t>
             </a:r>
           </a:p>
         </p:txBody>
@@ -6971,7 +7963,7 @@
                 </a:solidFill>
                 <a:latin typeface="Noto Sans CJK KR"/>
               </a:rPr>
-              <a:t>12F: 왜 떨어졌나 — background_polish가 굶었다</a:t>
+              <a:t>map()이 주기적으로 폴리시 기회를 통째로 삼킨다</a:t>
             </a:r>
           </a:p>
         </p:txBody>
@@ -7022,7 +8014,7 @@
       </p:sp>
       <p:pic>
         <p:nvPicPr>
-          <p:cNvPr id="6" name="Picture 5" descr="fig_polish_collapse.png"/>
+          <p:cNvPr id="6" name="Picture 5" descr="fig_macro_timeline.png"/>
           <p:cNvPicPr>
             <a:picLocks noChangeAspect="1"/>
           </p:cNvPicPr>
@@ -7036,8 +8028,8 @@
         </p:blipFill>
         <p:spPr>
           <a:xfrm>
-            <a:off x="2974632" y="1280160"/>
-            <a:ext cx="6242429" cy="3931920"/>
+            <a:off x="548640" y="1471220"/>
+            <a:ext cx="11094415" cy="4829959"/>
           </a:xfrm>
           <a:prstGeom prst="rect">
             <a:avLst/>
@@ -7052,8 +8044,8 @@
         </p:nvSpPr>
         <p:spPr>
           <a:xfrm>
-            <a:off x="548640" y="5394960"/>
-            <a:ext cx="11094415" cy="1005840"/>
+            <a:off x="548640" y="6537960"/>
+            <a:ext cx="11094415" cy="274320"/>
           </a:xfrm>
           <a:prstGeom prst="rect">
             <a:avLst/>
@@ -7068,17 +8060,17 @@
           <a:p>
             <a:pPr algn="l">
               <a:lnSpc>
-                <a:spcPct val="125000"/>
+                <a:spcPct val="120000"/>
               </a:lnSpc>
             </a:pPr>
             <a:r>
-              <a:rPr sz="1250" b="0">
+              <a:rPr sz="1150" b="0">
                 <a:solidFill>
                   <a:srgbClr val="8B95AB"/>
                 </a:solidFill>
                 <a:latin typeface="Noto Sans CJK KR"/>
               </a:rPr>
-              <a:t>A2가 keyframe을 298→352개로 촘촘히 뽑으면서 tracking/mapping이 더 오래 바빠졌고, 그만큼 background_polish가 돌 idle 시간이 사라졌다(6,586→772 step, -88%). 12F는 원래(sparse 설정) 이미 keyframe 밀도가 충분한 장면(58.7개/프레임, 305는 29.7개/프레임)이라 — 촘촘하게 뽑는 "이득"은 거의 없이 "polish 손해"만 봤다.</a:t>
+              <a:t>polish 횟수를 결정하는 건 "프레임당 idle"과 "map()이 전체 시간의 몇 %를 먹는지" 두 가지 — scale을 올리면 이 둘이 같은 방향으로 움직여 폴리시 기회가 넓어진다.</a:t>
             </a:r>
           </a:p>
         </p:txBody>
@@ -7179,7 +8171,7 @@
                 </a:solidFill>
                 <a:latin typeface="Noto Sans CJK KR"/>
               </a:rPr>
-              <a:t>THE MENTAL MODEL</a:t>
+              <a:t>EVIDENCE #1</a:t>
             </a:r>
           </a:p>
         </p:txBody>
@@ -7218,7 +8210,7 @@
                 </a:solidFill>
                 <a:latin typeface="Noto Sans CJK KR"/>
               </a:rPr>
-              <a:t>같은 다이얼, 장면마다 반대로 작용하는 이유</a:t>
+              <a:t>같은 파라미터, 정반대 결과 — 실측</a:t>
             </a:r>
           </a:p>
         </p:txBody>
@@ -7269,7 +8261,7 @@
       </p:sp>
       <p:pic>
         <p:nvPicPr>
-          <p:cNvPr id="6" name="Picture 5" descr="fig_tradeoff_concept.png"/>
+          <p:cNvPr id="6" name="Picture 5" descr="fig_a2_scene_flip.png"/>
           <p:cNvPicPr>
             <a:picLocks noChangeAspect="1"/>
           </p:cNvPicPr>
@@ -7283,8 +8275,8 @@
         </p:blipFill>
         <p:spPr>
           <a:xfrm>
-            <a:off x="2895359" y="1280160"/>
-            <a:ext cx="6400976" cy="3703320"/>
+            <a:off x="2997283" y="1280160"/>
+            <a:ext cx="6197127" cy="3794760"/>
           </a:xfrm>
           <a:prstGeom prst="rect">
             <a:avLst/>
@@ -7293,39 +8285,207 @@
       </p:pic>
       <p:sp>
         <p:nvSpPr>
-          <p:cNvPr id="7" name="TextBox 6"/>
-          <p:cNvSpPr txBox="1"/>
+          <p:cNvPr id="7" name="Rounded Rectangle 6"/>
+          <p:cNvSpPr/>
           <p:nvPr/>
         </p:nvSpPr>
         <p:spPr>
           <a:xfrm>
             <a:off x="548640" y="5257800"/>
-            <a:ext cx="11094415" cy="1051560"/>
-          </a:xfrm>
-          <a:prstGeom prst="rect">
-            <a:avLst/>
-          </a:prstGeom>
-          <a:noFill/>
-        </p:spPr>
-        <p:txBody>
-          <a:bodyPr wrap="square" anchor="t">
-            <a:spAutoFit/>
-          </a:bodyPr>
-          <a:lstStyle/>
-          <a:p>
-            <a:pPr algn="l">
-              <a:lnSpc>
-                <a:spcPct val="125000"/>
-              </a:lnSpc>
-            </a:pPr>
-            <a:r>
-              <a:rPr sz="1200" b="0">
+            <a:ext cx="3566160" cy="1005840"/>
+          </a:xfrm>
+          <a:prstGeom prst="roundRect">
+            <a:avLst>
+              <a:gd name="adj" fmla="val 8000"/>
+            </a:avLst>
+          </a:prstGeom>
+          <a:solidFill>
+            <a:srgbClr val="1A1F2B"/>
+          </a:solidFill>
+          <a:ln w="15875">
+            <a:solidFill>
+              <a:srgbClr val="5FD68A"/>
+            </a:solidFill>
+          </a:ln>
+          <a:effectLst/>
+        </p:spPr>
+        <p:style>
+          <a:lnRef idx="1">
+            <a:schemeClr val="accent1"/>
+          </a:lnRef>
+          <a:fillRef idx="3">
+            <a:schemeClr val="accent1"/>
+          </a:fillRef>
+          <a:effectRef idx="2">
+            <a:schemeClr val="accent1"/>
+          </a:effectRef>
+          <a:fontRef idx="minor">
+            <a:schemeClr val="lt1"/>
+          </a:fontRef>
+        </p:style>
+        <p:txBody>
+          <a:bodyPr rtlCol="0" anchor="ctr" wrap="square" lIns="146304" rIns="146304"/>
+          <a:lstStyle/>
+          <a:p>
+            <a:pPr algn="ctr"/>
+            <a:r>
+              <a:rPr sz="2200" b="1">
+                <a:solidFill>
+                  <a:srgbClr val="5FD68A"/>
+                </a:solidFill>
+                <a:latin typeface="Noto Sans CJK KR"/>
+              </a:rPr>
+              <a:t>+7.00 dB</a:t>
+            </a:r>
+          </a:p>
+          <a:p>
+            <a:pPr algn="ctr"/>
+            <a:r>
+              <a:rPr sz="1050">
                 <a:solidFill>
                   <a:srgbClr val="8B95AB"/>
                 </a:solidFill>
                 <a:latin typeface="Noto Sans CJK KR"/>
               </a:rPr>
-              <a:t>※ 개념도 — 12F의 "이득 0"은 정밀 분해가 아니라 관측된 순효과(-4.84dB)를 설명하는 단순화된 예시다. 실제 이득/손해를 분리해서 재려면 아래 계측 정비가 선행돼야 한다. 핵심은 "keyframe 밀도"라는 하나의 다이얼이 두 개의 서로 다른 효과(커버리지 개선 vs polish 굶주림)를 동시에 만든다는 것.</a:t>
+              <a:t>305 (원래 부족)</a:t>
+            </a:r>
+          </a:p>
+        </p:txBody>
+      </p:sp>
+      <p:sp>
+        <p:nvSpPr>
+          <p:cNvPr id="8" name="Rounded Rectangle 7"/>
+          <p:cNvSpPr/>
+          <p:nvPr/>
+        </p:nvSpPr>
+        <p:spPr>
+          <a:xfrm>
+            <a:off x="4297679" y="5257800"/>
+            <a:ext cx="3566160" cy="1005840"/>
+          </a:xfrm>
+          <a:prstGeom prst="roundRect">
+            <a:avLst>
+              <a:gd name="adj" fmla="val 8000"/>
+            </a:avLst>
+          </a:prstGeom>
+          <a:solidFill>
+            <a:srgbClr val="1A1F2B"/>
+          </a:solidFill>
+          <a:ln w="15875">
+            <a:solidFill>
+              <a:srgbClr val="EF6A5C"/>
+            </a:solidFill>
+          </a:ln>
+          <a:effectLst/>
+        </p:spPr>
+        <p:style>
+          <a:lnRef idx="1">
+            <a:schemeClr val="accent1"/>
+          </a:lnRef>
+          <a:fillRef idx="3">
+            <a:schemeClr val="accent1"/>
+          </a:fillRef>
+          <a:effectRef idx="2">
+            <a:schemeClr val="accent1"/>
+          </a:effectRef>
+          <a:fontRef idx="minor">
+            <a:schemeClr val="lt1"/>
+          </a:fontRef>
+        </p:style>
+        <p:txBody>
+          <a:bodyPr rtlCol="0" anchor="ctr" wrap="square" lIns="146304" rIns="146304"/>
+          <a:lstStyle/>
+          <a:p>
+            <a:pPr algn="ctr"/>
+            <a:r>
+              <a:rPr sz="2200" b="1">
+                <a:solidFill>
+                  <a:srgbClr val="EF6A5C"/>
+                </a:solidFill>
+                <a:latin typeface="Noto Sans CJK KR"/>
+              </a:rPr>
+              <a:t>-4.84 dB</a:t>
+            </a:r>
+          </a:p>
+          <a:p>
+            <a:pPr algn="ctr"/>
+            <a:r>
+              <a:rPr sz="1050">
+                <a:solidFill>
+                  <a:srgbClr val="8B95AB"/>
+                </a:solidFill>
+                <a:latin typeface="Noto Sans CJK KR"/>
+              </a:rPr>
+              <a:t>12F (원래 충분)</a:t>
+            </a:r>
+          </a:p>
+        </p:txBody>
+      </p:sp>
+      <p:sp>
+        <p:nvSpPr>
+          <p:cNvPr id="9" name="Rounded Rectangle 8"/>
+          <p:cNvSpPr/>
+          <p:nvPr/>
+        </p:nvSpPr>
+        <p:spPr>
+          <a:xfrm>
+            <a:off x="8046719" y="5257800"/>
+            <a:ext cx="3657600" cy="1005840"/>
+          </a:xfrm>
+          <a:prstGeom prst="roundRect">
+            <a:avLst>
+              <a:gd name="adj" fmla="val 8000"/>
+            </a:avLst>
+          </a:prstGeom>
+          <a:solidFill>
+            <a:srgbClr val="1A1F2B"/>
+          </a:solidFill>
+          <a:ln w="15875">
+            <a:solidFill>
+              <a:srgbClr val="FFB454"/>
+            </a:solidFill>
+          </a:ln>
+          <a:effectLst/>
+        </p:spPr>
+        <p:style>
+          <a:lnRef idx="1">
+            <a:schemeClr val="accent1"/>
+          </a:lnRef>
+          <a:fillRef idx="3">
+            <a:schemeClr val="accent1"/>
+          </a:fillRef>
+          <a:effectRef idx="2">
+            <a:schemeClr val="accent1"/>
+          </a:effectRef>
+          <a:fontRef idx="minor">
+            <a:schemeClr val="lt1"/>
+          </a:fontRef>
+        </p:style>
+        <p:txBody>
+          <a:bodyPr rtlCol="0" anchor="ctr" wrap="square" lIns="146304" rIns="146304"/>
+          <a:lstStyle/>
+          <a:p>
+            <a:pPr algn="ctr"/>
+            <a:r>
+              <a:rPr sz="2200" b="1">
+                <a:solidFill>
+                  <a:srgbClr val="FFB454"/>
+                </a:solidFill>
+                <a:latin typeface="Noto Sans CJK KR"/>
+              </a:rPr>
+              <a:t>12F 미검증 방치</a:t>
+            </a:r>
+          </a:p>
+          <a:p>
+            <a:pPr algn="ctr"/>
+            <a:r>
+              <a:rPr sz="1050">
+                <a:solidFill>
+                  <a:srgbClr val="8B95AB"/>
+                </a:solidFill>
+                <a:latin typeface="Noto Sans CJK KR"/>
+              </a:rPr>
+              <a:t>검증 상태</a:t>
             </a:r>
           </a:p>
         </p:txBody>
@@ -7426,7 +8586,7 @@
                 </a:solidFill>
                 <a:latin typeface="Noto Sans CJK KR"/>
               </a:rPr>
-              <a:t>INSTRUMENTATION · DONE</a:t>
+              <a:t>EVIDENCE #2</a:t>
             </a:r>
           </a:p>
         </p:txBody>
@@ -7465,7 +8625,7 @@
                 </a:solidFill>
                 <a:latin typeface="Noto Sans CJK KR"/>
               </a:rPr>
-              <a:t>있는 계측 vs 없는 계측 — 빈 구멍은 메웠다</a:t>
+              <a:t>12F: 왜 떨어졌나 — background_polish가 굶었다</a:t>
             </a:r>
           </a:p>
         </p:txBody>
@@ -7516,7 +8676,7 @@
       </p:sp>
       <p:pic>
         <p:nvPicPr>
-          <p:cNvPr id="6" name="Picture 5" descr="fig_instrumentation.png"/>
+          <p:cNvPr id="6" name="Picture 5" descr="fig_polish_collapse.png"/>
           <p:cNvPicPr>
             <a:picLocks noChangeAspect="1"/>
           </p:cNvPicPr>
@@ -7530,8 +8690,8 @@
         </p:blipFill>
         <p:spPr>
           <a:xfrm>
-            <a:off x="2580182" y="1280160"/>
-            <a:ext cx="7031330" cy="3931920"/>
+            <a:off x="2974632" y="1280160"/>
+            <a:ext cx="6242429" cy="3931920"/>
           </a:xfrm>
           <a:prstGeom prst="rect">
             <a:avLst/>
@@ -7568,11 +8728,11 @@
             <a:r>
               <a:rPr sz="1250" b="0">
                 <a:solidFill>
-                  <a:srgbClr val="5FD68A"/>
-                </a:solidFill>
-                <a:latin typeface="Noto Sans CJK KR"/>
-              </a:rPr>
-              <a:t>`VIGS_TIMING_LOG`는 이미 있었지만 이번 세션 내내 한 번도 안 켠 상태였다 — 지금 켜서 4개 런(12F pre-A2/A2, 305 A2, 12F A2 재검증)을 재분석했다. 유일한 빈 구멍이었던 `background_polish_step` 내부에도 `_Sect` 패턴으로 계측을 추가(`gs_backend.py:1607,2099` 근처, n_gauss/scope/batch_size 컨텍스트 포함)해서 이제 완전히 커버된다.</a:t>
+                  <a:srgbClr val="8B95AB"/>
+                </a:solidFill>
+                <a:latin typeface="Noto Sans CJK KR"/>
+              </a:rPr>
+              <a:t>A2가 keyframe을 298→352개로 촘촘히 뽑으면서 tracking/mapping이 더 오래 바빠졌고, 그만큼 background_polish가 돌 idle 시간이 사라졌다(6,586→772 step, -88%). 12F는 원래(sparse 설정) 이미 keyframe 밀도가 충분한 장면(58.7개/프레임, 305는 29.7개/프레임)이라 — 촘촘하게 뽑는 "이득"은 거의 없이 "polish 손해"만 봤다.</a:t>
             </a:r>
           </a:p>
         </p:txBody>
@@ -7673,7 +8833,7 @@
                 </a:solidFill>
                 <a:latin typeface="Noto Sans CJK KR"/>
               </a:rPr>
-              <a:t>MEASURED · STEP 1</a:t>
+              <a:t>THE MENTAL MODEL</a:t>
             </a:r>
           </a:p>
         </p:txBody>
@@ -7712,7 +8872,7 @@
                 </a:solidFill>
                 <a:latin typeface="Noto Sans CJK KR"/>
               </a:rPr>
-              <a:t>실측 결과 ① — frontend가 진짜 지배적이다</a:t>
+              <a:t>같은 다이얼, 장면마다 반대로 작용하는 이유</a:t>
             </a:r>
           </a:p>
         </p:txBody>
@@ -7763,7 +8923,7 @@
       </p:sp>
       <p:pic>
         <p:nvPicPr>
-          <p:cNvPr id="6" name="Picture 5" descr="fig_frontend_scaling.png"/>
+          <p:cNvPr id="6" name="Picture 5" descr="fig_tradeoff_concept.png"/>
           <p:cNvPicPr>
             <a:picLocks noChangeAspect="1"/>
           </p:cNvPicPr>
@@ -7777,8 +8937,8 @@
         </p:blipFill>
         <p:spPr>
           <a:xfrm>
-            <a:off x="3111452" y="1280160"/>
-            <a:ext cx="5968790" cy="3794760"/>
+            <a:off x="2895359" y="1280160"/>
+            <a:ext cx="6400976" cy="3703320"/>
           </a:xfrm>
           <a:prstGeom prst="rect">
             <a:avLst/>
@@ -7787,207 +8947,39 @@
       </p:pic>
       <p:sp>
         <p:nvSpPr>
-          <p:cNvPr id="7" name="Rounded Rectangle 6"/>
-          <p:cNvSpPr/>
+          <p:cNvPr id="7" name="TextBox 6"/>
+          <p:cNvSpPr txBox="1"/>
           <p:nvPr/>
         </p:nvSpPr>
         <p:spPr>
           <a:xfrm>
             <a:off x="548640" y="5257800"/>
-            <a:ext cx="3566160" cy="1005840"/>
-          </a:xfrm>
-          <a:prstGeom prst="roundRect">
-            <a:avLst>
-              <a:gd name="adj" fmla="val 8000"/>
-            </a:avLst>
-          </a:prstGeom>
-          <a:solidFill>
-            <a:srgbClr val="1A1F2B"/>
-          </a:solidFill>
-          <a:ln w="15875">
-            <a:solidFill>
-              <a:srgbClr val="EF6A5C"/>
-            </a:solidFill>
-          </a:ln>
-          <a:effectLst/>
-        </p:spPr>
-        <p:style>
-          <a:lnRef idx="1">
-            <a:schemeClr val="accent1"/>
-          </a:lnRef>
-          <a:fillRef idx="3">
-            <a:schemeClr val="accent1"/>
-          </a:fillRef>
-          <a:effectRef idx="2">
-            <a:schemeClr val="accent1"/>
-          </a:effectRef>
-          <a:fontRef idx="minor">
-            <a:schemeClr val="lt1"/>
-          </a:fontRef>
-        </p:style>
-        <p:txBody>
-          <a:bodyPr rtlCol="0" anchor="ctr" wrap="square" lIns="146304" rIns="146304"/>
-          <a:lstStyle/>
-          <a:p>
-            <a:pPr algn="ctr"/>
-            <a:r>
-              <a:rPr sz="2200" b="1">
-                <a:solidFill>
-                  <a:srgbClr val="EF6A5C"/>
-                </a:solidFill>
-                <a:latin typeface="Noto Sans CJK KR"/>
-              </a:rPr>
-              <a:t>73.4%</a:t>
-            </a:r>
-          </a:p>
-          <a:p>
-            <a:pPr algn="ctr"/>
-            <a:r>
-              <a:rPr sz="1050">
+            <a:ext cx="11094415" cy="1051560"/>
+          </a:xfrm>
+          <a:prstGeom prst="rect">
+            <a:avLst/>
+          </a:prstGeom>
+          <a:noFill/>
+        </p:spPr>
+        <p:txBody>
+          <a:bodyPr wrap="square" anchor="t">
+            <a:spAutoFit/>
+          </a:bodyPr>
+          <a:lstStyle/>
+          <a:p>
+            <a:pPr algn="l">
+              <a:lnSpc>
+                <a:spcPct val="125000"/>
+              </a:lnSpc>
+            </a:pPr>
+            <a:r>
+              <a:rPr sz="1200" b="0">
                 <a:solidFill>
                   <a:srgbClr val="8B95AB"/>
                 </a:solidFill>
                 <a:latin typeface="Noto Sans CJK KR"/>
               </a:rPr>
-              <a:t>12F A2 frontend 비중</a:t>
-            </a:r>
-          </a:p>
-        </p:txBody>
-      </p:sp>
-      <p:sp>
-        <p:nvSpPr>
-          <p:cNvPr id="8" name="Rounded Rectangle 7"/>
-          <p:cNvSpPr/>
-          <p:nvPr/>
-        </p:nvSpPr>
-        <p:spPr>
-          <a:xfrm>
-            <a:off x="4297679" y="5257800"/>
-            <a:ext cx="3566160" cy="1005840"/>
-          </a:xfrm>
-          <a:prstGeom prst="roundRect">
-            <a:avLst>
-              <a:gd name="adj" fmla="val 8000"/>
-            </a:avLst>
-          </a:prstGeom>
-          <a:solidFill>
-            <a:srgbClr val="1A1F2B"/>
-          </a:solidFill>
-          <a:ln w="15875">
-            <a:solidFill>
-              <a:srgbClr val="FFB454"/>
-            </a:solidFill>
-          </a:ln>
-          <a:effectLst/>
-        </p:spPr>
-        <p:style>
-          <a:lnRef idx="1">
-            <a:schemeClr val="accent1"/>
-          </a:lnRef>
-          <a:fillRef idx="3">
-            <a:schemeClr val="accent1"/>
-          </a:fillRef>
-          <a:effectRef idx="2">
-            <a:schemeClr val="accent1"/>
-          </a:effectRef>
-          <a:fontRef idx="minor">
-            <a:schemeClr val="lt1"/>
-          </a:fontRef>
-        </p:style>
-        <p:txBody>
-          <a:bodyPr rtlCol="0" anchor="ctr" wrap="square" lIns="146304" rIns="146304"/>
-          <a:lstStyle/>
-          <a:p>
-            <a:pPr algn="ctr"/>
-            <a:r>
-              <a:rPr sz="2200" b="1">
-                <a:solidFill>
-                  <a:srgbClr val="FFB454"/>
-                </a:solidFill>
-                <a:latin typeface="Noto Sans CJK KR"/>
-              </a:rPr>
-              <a:t>×2.17</a:t>
-            </a:r>
-          </a:p>
-          <a:p>
-            <a:pPr algn="ctr"/>
-            <a:r>
-              <a:rPr sz="1050">
-                <a:solidFill>
-                  <a:srgbClr val="8B95AB"/>
-                </a:solidFill>
-                <a:latin typeface="Noto Sans CJK KR"/>
-              </a:rPr>
-              <a:t>iters1 1→2 배율</a:t>
-            </a:r>
-          </a:p>
-        </p:txBody>
-      </p:sp>
-      <p:sp>
-        <p:nvSpPr>
-          <p:cNvPr id="9" name="Rounded Rectangle 8"/>
-          <p:cNvSpPr/>
-          <p:nvPr/>
-        </p:nvSpPr>
-        <p:spPr>
-          <a:xfrm>
-            <a:off x="8046719" y="5257800"/>
-            <a:ext cx="3657600" cy="1005840"/>
-          </a:xfrm>
-          <a:prstGeom prst="roundRect">
-            <a:avLst>
-              <a:gd name="adj" fmla="val 8000"/>
-            </a:avLst>
-          </a:prstGeom>
-          <a:solidFill>
-            <a:srgbClr val="1A1F2B"/>
-          </a:solidFill>
-          <a:ln w="15875">
-            <a:solidFill>
-              <a:srgbClr val="8B95AB"/>
-            </a:solidFill>
-          </a:ln>
-          <a:effectLst/>
-        </p:spPr>
-        <p:style>
-          <a:lnRef idx="1">
-            <a:schemeClr val="accent1"/>
-          </a:lnRef>
-          <a:fillRef idx="3">
-            <a:schemeClr val="accent1"/>
-          </a:fillRef>
-          <a:effectRef idx="2">
-            <a:schemeClr val="accent1"/>
-          </a:effectRef>
-          <a:fontRef idx="minor">
-            <a:schemeClr val="lt1"/>
-          </a:fontRef>
-        </p:style>
-        <p:txBody>
-          <a:bodyPr rtlCol="0" anchor="ctr" wrap="square" lIns="146304" rIns="146304"/>
-          <a:lstStyle/>
-          <a:p>
-            <a:pPr algn="ctr"/>
-            <a:r>
-              <a:rPr sz="2200" b="1">
-                <a:solidFill>
-                  <a:srgbClr val="8B95AB"/>
-                </a:solidFill>
-                <a:latin typeface="Noto Sans CJK KR"/>
-              </a:rPr>
-              <a:t>1.2~1.7%</a:t>
-            </a:r>
-          </a:p>
-          <a:p>
-            <a:pPr algn="ctr"/>
-            <a:r>
-              <a:rPr sz="1050">
-                <a:solidFill>
-                  <a:srgbClr val="8B95AB"/>
-                </a:solidFill>
-                <a:latin typeface="Noto Sans CJK KR"/>
-              </a:rPr>
-              <a:t>gs_mapping(디스패치) 비중</a:t>
+              <a:t>※ 개념도 — 12F의 "이득 0"은 정밀 분해가 아니라 관측된 순효과(-4.84dB)를 설명하는 단순화된 예시다. 실제 이득/손해를 분리해서 재려면 아래 계측 정비가 선행돼야 한다. 핵심은 "keyframe 밀도"라는 하나의 다이얼이 두 개의 서로 다른 효과(커버리지 개선 vs polish 굶주림)를 동시에 만든다는 것.</a:t>
             </a:r>
           </a:p>
         </p:txBody>
@@ -8088,7 +9080,7 @@
                 </a:solidFill>
                 <a:latin typeface="Noto Sans CJK KR"/>
               </a:rPr>
-              <a:t>MEASURED · STEP 2</a:t>
+              <a:t>INSTRUMENTATION · DONE</a:t>
             </a:r>
           </a:p>
         </p:txBody>
@@ -8127,7 +9119,7 @@
                 </a:solidFill>
                 <a:latin typeface="Noto Sans CJK KR"/>
               </a:rPr>
-              <a:t>실측 결과 ② — polish는 "느려진 게" 아니라 "기회가 없었다"</a:t>
+              <a:t>있는 계측 vs 없는 계측 — 빈 구멍은 메웠다</a:t>
             </a:r>
           </a:p>
         </p:txBody>
@@ -8178,7 +9170,7 @@
       </p:sp>
       <p:pic>
         <p:nvPicPr>
-          <p:cNvPr id="6" name="Picture 5" descr="fig_polish_opportunity.png"/>
+          <p:cNvPr id="6" name="Picture 5" descr="fig_instrumentation.png"/>
           <p:cNvPicPr>
             <a:picLocks noChangeAspect="1"/>
           </p:cNvPicPr>
@@ -8192,8 +9184,8 @@
         </p:blipFill>
         <p:spPr>
           <a:xfrm>
-            <a:off x="2929308" y="1280160"/>
-            <a:ext cx="6333078" cy="3794760"/>
+            <a:off x="2580182" y="1280160"/>
+            <a:ext cx="7031330" cy="3931920"/>
           </a:xfrm>
           <a:prstGeom prst="rect">
             <a:avLst/>
@@ -8208,7 +9200,7 @@
         </p:nvSpPr>
         <p:spPr>
           <a:xfrm>
-            <a:off x="548640" y="5257800"/>
+            <a:off x="548640" y="5394960"/>
             <a:ext cx="11094415" cy="1005840"/>
           </a:xfrm>
           <a:prstGeom prst="rect">
@@ -8230,11 +9222,11 @@
             <a:r>
               <a:rPr sz="1250" b="0">
                 <a:solidFill>
-                  <a:srgbClr val="E8ECF4"/>
-                </a:solidFill>
-                <a:latin typeface="Noto Sans CJK KR"/>
-              </a:rPr>
-              <a:t>핵심 확인: call당 비용(3.9~6.4ms)은 gaussian 수(40k~150k)에 걸쳐 거의 고정 — 미세한 n_gauss 의존성은 있지만(약 1.5배 범위) 기회 횟수 차이(13배)에 비하면 훨씬 작다. 즉 exp카드에 남겼던 "772 step이 idle 부족 때문인지 step 자체가 느려서인지" 질문의 답은 확정적으로 idle 부족 쪽이다.</a:t>
+                  <a:srgbClr val="5FD68A"/>
+                </a:solidFill>
+                <a:latin typeface="Noto Sans CJK KR"/>
+              </a:rPr>
+              <a:t>`VIGS_TIMING_LOG`는 이미 있었지만 이번 세션 내내 한 번도 안 켠 상태였다 — 지금 켜서 4개 런(12F pre-A2/A2, 305 A2, 12F A2 재검증)을 재분석했다. 유일한 빈 구멍이었던 `background_polish_step` 내부에도 `_Sect` 패턴으로 계측을 추가(`gs_backend.py:1607,2099` 근처, n_gauss/scope/batch_size 컨텍스트 포함)해서 이제 완전히 커버된다.</a:t>
             </a:r>
           </a:p>
         </p:txBody>

</xml_diff>